<commit_message>
Redesign Unit 6 PPTs with bordered centered layout
Reference 古诗四首 PPT for frame/centering patterns; each lesson gets
a distinct visual theme (museum, xianxia, palace, myth, scroll, festive)
with corner decorations, content panels, and numbered bullets.

Co-authored-by: Lin Silentium <decemberlin54-del@users.noreply.github.com>
</commit_message>
<xml_diff>
--- a/第六单元PPT/第21课 小圣施威降大圣.pptx
+++ b/第六单元PPT/第21课 小圣施威降大圣.pptx
@@ -3128,17 +3128,17 @@
         </p:nvSpPr>
         <p:spPr>
           <a:xfrm>
-            <a:off x="0" y="0"/>
-            <a:ext cx="12191695" cy="6858000"/>
-          </a:xfrm>
-          <a:prstGeom prst="rect">
-            <a:avLst/>
-          </a:prstGeom>
-          <a:solidFill>
-            <a:srgbClr val="FCFAF7"/>
-          </a:solidFill>
-          <a:ln>
-            <a:noFill/>
+            <a:off x="292608" y="274320"/>
+            <a:ext cx="11594592" cy="6300216"/>
+          </a:xfrm>
+          <a:prstGeom prst="rect">
+            <a:avLst/>
+          </a:prstGeom>
+          <a:noFill/>
+          <a:ln w="31750">
+            <a:solidFill>
+              <a:srgbClr val="C85A32"/>
+            </a:solidFill>
           </a:ln>
         </p:spPr>
         <p:style>
@@ -3163,25 +3163,73 @@
           </a:p>
         </p:txBody>
       </p:sp>
-      <p:sp>
-        <p:nvSpPr>
-          <p:cNvPr id="4" name="Rectangle 3"/>
+      <p:pic>
+        <p:nvPicPr>
+          <p:cNvPr id="4" name="Picture 3" descr="corner_wukong_tl.png"/>
+          <p:cNvPicPr>
+            <a:picLocks noChangeAspect="1"/>
+          </p:cNvPicPr>
+          <p:nvPr/>
+        </p:nvPicPr>
+        <p:blipFill>
+          <a:blip r:embed="rId3"/>
+          <a:stretch>
+            <a:fillRect/>
+          </a:stretch>
+        </p:blipFill>
+        <p:spPr>
+          <a:xfrm>
+            <a:off x="-45720" y="-45720"/>
+            <a:ext cx="2011680" cy="2011680"/>
+          </a:xfrm>
+          <a:prstGeom prst="rect">
+            <a:avLst/>
+          </a:prstGeom>
+        </p:spPr>
+      </p:pic>
+      <p:pic>
+        <p:nvPicPr>
+          <p:cNvPr id="5" name="Picture 4" descr="corner_wukong_tr.png"/>
+          <p:cNvPicPr>
+            <a:picLocks noChangeAspect="1"/>
+          </p:cNvPicPr>
+          <p:nvPr/>
+        </p:nvPicPr>
+        <p:blipFill>
+          <a:blip r:embed="rId4"/>
+          <a:stretch>
+            <a:fillRect/>
+          </a:stretch>
+        </p:blipFill>
+        <p:spPr>
+          <a:xfrm>
+            <a:off x="9875520" y="-45720"/>
+            <a:ext cx="2011680" cy="2011680"/>
+          </a:xfrm>
+          <a:prstGeom prst="rect">
+            <a:avLst/>
+          </a:prstGeom>
+        </p:spPr>
+      </p:pic>
+      <p:sp>
+        <p:nvSpPr>
+          <p:cNvPr id="6" name="Rectangle 5"/>
           <p:cNvSpPr/>
           <p:nvPr/>
         </p:nvSpPr>
         <p:spPr>
           <a:xfrm>
-            <a:off x="0" y="2926080"/>
-            <a:ext cx="12191695" cy="73152"/>
-          </a:xfrm>
-          <a:prstGeom prst="rect">
-            <a:avLst/>
-          </a:prstGeom>
-          <a:solidFill>
-            <a:srgbClr val="FF7F66"/>
-          </a:solidFill>
-          <a:ln>
-            <a:noFill/>
+            <a:off x="292608" y="274320"/>
+            <a:ext cx="11594592" cy="6300216"/>
+          </a:xfrm>
+          <a:prstGeom prst="rect">
+            <a:avLst/>
+          </a:prstGeom>
+          <a:noFill/>
+          <a:ln w="31750">
+            <a:solidFill>
+              <a:srgbClr val="C85A32"/>
+            </a:solidFill>
           </a:ln>
         </p:spPr>
         <p:style>
@@ -3208,14 +3256,57 @@
       </p:sp>
       <p:sp>
         <p:nvSpPr>
-          <p:cNvPr id="5" name="TextBox 4"/>
+          <p:cNvPr id="7" name="Rectangle 6"/>
+          <p:cNvSpPr/>
+          <p:nvPr/>
+        </p:nvSpPr>
+        <p:spPr>
+          <a:xfrm>
+            <a:off x="347472" y="329184"/>
+            <a:ext cx="11484864" cy="6190488"/>
+          </a:xfrm>
+          <a:prstGeom prst="rect">
+            <a:avLst/>
+          </a:prstGeom>
+          <a:noFill/>
+          <a:ln w="12700">
+            <a:solidFill>
+              <a:srgbClr val="FFB464"/>
+            </a:solidFill>
+          </a:ln>
+        </p:spPr>
+        <p:style>
+          <a:lnRef idx="1">
+            <a:schemeClr val="accent1"/>
+          </a:lnRef>
+          <a:fillRef idx="3">
+            <a:schemeClr val="accent1"/>
+          </a:fillRef>
+          <a:effectRef idx="2">
+            <a:schemeClr val="accent1"/>
+          </a:effectRef>
+          <a:fontRef idx="minor">
+            <a:schemeClr val="lt1"/>
+          </a:fontRef>
+        </p:style>
+        <p:txBody>
+          <a:bodyPr rtlCol="0" anchor="ctr"/>
+          <a:lstStyle/>
+          <a:p>
+            <a:pPr algn="ctr"/>
+          </a:p>
+        </p:txBody>
+      </p:sp>
+      <p:sp>
+        <p:nvSpPr>
+          <p:cNvPr id="8" name="TextBox 7"/>
           <p:cNvSpPr txBox="1"/>
           <p:nvPr/>
         </p:nvSpPr>
         <p:spPr>
           <a:xfrm>
-            <a:off x="914400" y="2286000"/>
-            <a:ext cx="10058400" cy="1371600"/>
+            <a:off x="1371600" y="2011680"/>
+            <a:ext cx="9418320" cy="1645920"/>
           </a:xfrm>
           <a:prstGeom prst="rect">
             <a:avLst/>
@@ -3228,51 +3319,79 @@
           </a:bodyPr>
           <a:lstStyle/>
           <a:p>
-            <a:pPr algn="ctr"/>
+            <a:pPr algn="ctr">
+              <a:spcAft>
+                <a:spcPts val="1000"/>
+              </a:spcAft>
+            </a:pPr>
             <a:r>
               <a:rPr sz="5200" b="1">
                 <a:solidFill>
-                  <a:srgbClr val="5A606E"/>
+                  <a:srgbClr val="DC5028"/>
                 </a:solidFill>
                 <a:latin typeface="Microsoft YaHei"/>
               </a:rPr>
               <a:t>小圣施威降大圣</a:t>
             </a:r>
           </a:p>
-        </p:txBody>
-      </p:sp>
-      <p:sp>
-        <p:nvSpPr>
-          <p:cNvPr id="6" name="TextBox 5"/>
-          <p:cNvSpPr txBox="1"/>
-          <p:nvPr/>
-        </p:nvSpPr>
-        <p:spPr>
-          <a:xfrm>
-            <a:off x="914400" y="3657600"/>
-            <a:ext cx="10058400" cy="914400"/>
-          </a:xfrm>
-          <a:prstGeom prst="rect">
-            <a:avLst/>
-          </a:prstGeom>
-          <a:noFill/>
-        </p:spPr>
-        <p:txBody>
-          <a:bodyPr wrap="none">
-            <a:spAutoFit/>
-          </a:bodyPr>
-          <a:lstStyle/>
-          <a:p>
-            <a:pPr algn="ctr"/>
-            <a:r>
-              <a:rPr sz="2800" b="0">
+          <a:p>
+            <a:pPr algn="ctr">
+              <a:spcAft>
+                <a:spcPts val="1000"/>
+              </a:spcAft>
+            </a:pPr>
+            <a:r>
+              <a:rPr sz="2600" b="0">
                 <a:solidFill>
-                  <a:srgbClr val="FF7F66"/>
+                  <a:srgbClr val="502814"/>
                 </a:solidFill>
                 <a:latin typeface="Microsoft YaHei"/>
               </a:rPr>
               <a:t>第21课 · 第二、三课时 · 自由与规则</a:t>
             </a:r>
+          </a:p>
+        </p:txBody>
+      </p:sp>
+      <p:sp>
+        <p:nvSpPr>
+          <p:cNvPr id="9" name="Rectangle 8"/>
+          <p:cNvSpPr/>
+          <p:nvPr/>
+        </p:nvSpPr>
+        <p:spPr>
+          <a:xfrm>
+            <a:off x="3200400" y="5029200"/>
+            <a:ext cx="5760720" cy="27432"/>
+          </a:xfrm>
+          <a:prstGeom prst="rect">
+            <a:avLst/>
+          </a:prstGeom>
+          <a:solidFill>
+            <a:srgbClr val="FFB464"/>
+          </a:solidFill>
+          <a:ln>
+            <a:noFill/>
+          </a:ln>
+        </p:spPr>
+        <p:style>
+          <a:lnRef idx="1">
+            <a:schemeClr val="accent1"/>
+          </a:lnRef>
+          <a:fillRef idx="3">
+            <a:schemeClr val="accent1"/>
+          </a:fillRef>
+          <a:effectRef idx="2">
+            <a:schemeClr val="accent1"/>
+          </a:effectRef>
+          <a:fontRef idx="minor">
+            <a:schemeClr val="lt1"/>
+          </a:fontRef>
+        </p:style>
+        <p:txBody>
+          <a:bodyPr rtlCol="0" anchor="ctr"/>
+          <a:lstStyle/>
+          <a:p>
+            <a:pPr algn="ctr"/>
           </a:p>
         </p:txBody>
       </p:sp>
@@ -3326,17 +3445,17 @@
         </p:nvSpPr>
         <p:spPr>
           <a:xfrm>
-            <a:off x="0" y="0"/>
-            <a:ext cx="12191695" cy="6858000"/>
-          </a:xfrm>
-          <a:prstGeom prst="rect">
-            <a:avLst/>
-          </a:prstGeom>
-          <a:solidFill>
-            <a:srgbClr val="FCFAF7"/>
-          </a:solidFill>
-          <a:ln>
-            <a:noFill/>
+            <a:off x="292608" y="274320"/>
+            <a:ext cx="11594592" cy="6300216"/>
+          </a:xfrm>
+          <a:prstGeom prst="rect">
+            <a:avLst/>
+          </a:prstGeom>
+          <a:noFill/>
+          <a:ln w="31750">
+            <a:solidFill>
+              <a:srgbClr val="C85A32"/>
+            </a:solidFill>
           </a:ln>
         </p:spPr>
         <p:style>
@@ -3361,22 +3480,70 @@
           </a:p>
         </p:txBody>
       </p:sp>
-      <p:sp>
-        <p:nvSpPr>
-          <p:cNvPr id="4" name="Rectangle 3"/>
+      <p:pic>
+        <p:nvPicPr>
+          <p:cNvPr id="4" name="Picture 3" descr="corner_wukong_tl.png"/>
+          <p:cNvPicPr>
+            <a:picLocks noChangeAspect="1"/>
+          </p:cNvPicPr>
+          <p:nvPr/>
+        </p:nvPicPr>
+        <p:blipFill>
+          <a:blip r:embed="rId3"/>
+          <a:stretch>
+            <a:fillRect/>
+          </a:stretch>
+        </p:blipFill>
+        <p:spPr>
+          <a:xfrm>
+            <a:off x="-45720" y="-45720"/>
+            <a:ext cx="2011680" cy="2011680"/>
+          </a:xfrm>
+          <a:prstGeom prst="rect">
+            <a:avLst/>
+          </a:prstGeom>
+        </p:spPr>
+      </p:pic>
+      <p:pic>
+        <p:nvPicPr>
+          <p:cNvPr id="5" name="Picture 4" descr="corner_wukong_tr.png"/>
+          <p:cNvPicPr>
+            <a:picLocks noChangeAspect="1"/>
+          </p:cNvPicPr>
+          <p:nvPr/>
+        </p:nvPicPr>
+        <p:blipFill>
+          <a:blip r:embed="rId4"/>
+          <a:stretch>
+            <a:fillRect/>
+          </a:stretch>
+        </p:blipFill>
+        <p:spPr>
+          <a:xfrm>
+            <a:off x="9875520" y="-45720"/>
+            <a:ext cx="2011680" cy="2011680"/>
+          </a:xfrm>
+          <a:prstGeom prst="rect">
+            <a:avLst/>
+          </a:prstGeom>
+        </p:spPr>
+      </p:pic>
+      <p:sp>
+        <p:nvSpPr>
+          <p:cNvPr id="6" name="Rounded Rectangle 5"/>
           <p:cNvSpPr/>
           <p:nvPr/>
         </p:nvSpPr>
         <p:spPr>
           <a:xfrm>
-            <a:off x="0" y="0"/>
-            <a:ext cx="12191695" cy="91440"/>
-          </a:xfrm>
-          <a:prstGeom prst="rect">
+            <a:off x="4953304" y="502920"/>
+            <a:ext cx="2286000" cy="411480"/>
+          </a:xfrm>
+          <a:prstGeom prst="roundRect">
             <a:avLst/>
           </a:prstGeom>
           <a:solidFill>
-            <a:srgbClr val="FF7F66"/>
+            <a:srgbClr val="FFB464"/>
           </a:solidFill>
           <a:ln>
             <a:noFill/>
@@ -3406,14 +3573,14 @@
       </p:sp>
       <p:sp>
         <p:nvSpPr>
-          <p:cNvPr id="5" name="TextBox 4"/>
+          <p:cNvPr id="7" name="TextBox 6"/>
           <p:cNvSpPr txBox="1"/>
           <p:nvPr/>
         </p:nvSpPr>
         <p:spPr>
           <a:xfrm>
-            <a:off x="640080" y="228600"/>
-            <a:ext cx="2743200" cy="457200"/>
+            <a:off x="4953304" y="521208"/>
+            <a:ext cx="2286000" cy="384048"/>
           </a:xfrm>
           <a:prstGeom prst="rect">
             <a:avLst/>
@@ -3426,10 +3593,15 @@
           </a:bodyPr>
           <a:lstStyle/>
           <a:p>
-            <a:r>
-              <a:rPr sz="2000" b="1">
+            <a:pPr algn="ctr">
+              <a:spcAft>
+                <a:spcPts val="1000"/>
+              </a:spcAft>
+            </a:pPr>
+            <a:r>
+              <a:rPr sz="1800" b="1">
                 <a:solidFill>
-                  <a:srgbClr val="FF7F66"/>
+                  <a:srgbClr val="502814"/>
                 </a:solidFill>
                 <a:latin typeface="Microsoft YaHei"/>
               </a:rPr>
@@ -3440,14 +3612,14 @@
       </p:sp>
       <p:sp>
         <p:nvSpPr>
-          <p:cNvPr id="6" name="TextBox 5"/>
+          <p:cNvPr id="8" name="TextBox 7"/>
           <p:cNvSpPr txBox="1"/>
           <p:nvPr/>
         </p:nvSpPr>
         <p:spPr>
           <a:xfrm>
-            <a:off x="640080" y="685800"/>
-            <a:ext cx="10515600" cy="914400"/>
+            <a:off x="1371600" y="960120"/>
+            <a:ext cx="9418320" cy="822960"/>
           </a:xfrm>
           <a:prstGeom prst="rect">
             <a:avLst/>
@@ -3455,15 +3627,20 @@
           <a:noFill/>
         </p:spPr>
         <p:txBody>
-          <a:bodyPr wrap="none">
+          <a:bodyPr wrap="square">
             <a:spAutoFit/>
           </a:bodyPr>
           <a:lstStyle/>
           <a:p>
+            <a:pPr algn="ctr">
+              <a:spcAft>
+                <a:spcPts val="1000"/>
+              </a:spcAft>
+            </a:pPr>
             <a:r>
               <a:rPr sz="3600" b="1">
                 <a:solidFill>
-                  <a:srgbClr val="5A606E"/>
+                  <a:srgbClr val="DC5028"/>
                 </a:solidFill>
                 <a:latin typeface="Microsoft YaHei"/>
               </a:rPr>
@@ -3474,14 +3651,145 @@
       </p:sp>
       <p:sp>
         <p:nvSpPr>
-          <p:cNvPr id="7" name="TextBox 6"/>
+          <p:cNvPr id="9" name="Rectangle 8"/>
+          <p:cNvSpPr/>
+          <p:nvPr/>
+        </p:nvSpPr>
+        <p:spPr>
+          <a:xfrm>
+            <a:off x="3200400" y="1600200"/>
+            <a:ext cx="5760720" cy="27432"/>
+          </a:xfrm>
+          <a:prstGeom prst="rect">
+            <a:avLst/>
+          </a:prstGeom>
+          <a:solidFill>
+            <a:srgbClr val="FFB464"/>
+          </a:solidFill>
+          <a:ln>
+            <a:noFill/>
+          </a:ln>
+        </p:spPr>
+        <p:style>
+          <a:lnRef idx="1">
+            <a:schemeClr val="accent1"/>
+          </a:lnRef>
+          <a:fillRef idx="3">
+            <a:schemeClr val="accent1"/>
+          </a:fillRef>
+          <a:effectRef idx="2">
+            <a:schemeClr val="accent1"/>
+          </a:effectRef>
+          <a:fontRef idx="minor">
+            <a:schemeClr val="lt1"/>
+          </a:fontRef>
+        </p:style>
+        <p:txBody>
+          <a:bodyPr rtlCol="0" anchor="ctr"/>
+          <a:lstStyle/>
+          <a:p>
+            <a:pPr algn="ctr"/>
+          </a:p>
+        </p:txBody>
+      </p:sp>
+      <p:sp>
+        <p:nvSpPr>
+          <p:cNvPr id="10" name="Rounded Rectangle 9"/>
+          <p:cNvSpPr/>
+          <p:nvPr/>
+        </p:nvSpPr>
+        <p:spPr>
+          <a:xfrm>
+            <a:off x="1295704" y="1645920"/>
+            <a:ext cx="9601200" cy="2240280"/>
+          </a:xfrm>
+          <a:prstGeom prst="roundRect">
+            <a:avLst/>
+          </a:prstGeom>
+          <a:solidFill>
+            <a:srgbClr val="FFF8F0"/>
+          </a:solidFill>
+          <a:ln w="19050">
+            <a:solidFill>
+              <a:srgbClr val="FFB464"/>
+            </a:solidFill>
+          </a:ln>
+        </p:spPr>
+        <p:style>
+          <a:lnRef idx="1">
+            <a:schemeClr val="accent1"/>
+          </a:lnRef>
+          <a:fillRef idx="3">
+            <a:schemeClr val="accent1"/>
+          </a:fillRef>
+          <a:effectRef idx="2">
+            <a:schemeClr val="accent1"/>
+          </a:effectRef>
+          <a:fontRef idx="minor">
+            <a:schemeClr val="lt1"/>
+          </a:fontRef>
+        </p:style>
+        <p:txBody>
+          <a:bodyPr rtlCol="0" anchor="ctr"/>
+          <a:lstStyle/>
+          <a:p>
+            <a:pPr algn="ctr"/>
+          </a:p>
+        </p:txBody>
+      </p:sp>
+      <p:sp>
+        <p:nvSpPr>
+          <p:cNvPr id="11" name="Oval 10"/>
+          <p:cNvSpPr/>
+          <p:nvPr/>
+        </p:nvSpPr>
+        <p:spPr>
+          <a:xfrm>
+            <a:off x="2255824" y="1828800"/>
+            <a:ext cx="384048" cy="384048"/>
+          </a:xfrm>
+          <a:prstGeom prst="ellipse">
+            <a:avLst/>
+          </a:prstGeom>
+          <a:solidFill>
+            <a:srgbClr val="DC5028"/>
+          </a:solidFill>
+          <a:ln>
+            <a:noFill/>
+          </a:ln>
+        </p:spPr>
+        <p:style>
+          <a:lnRef idx="1">
+            <a:schemeClr val="accent1"/>
+          </a:lnRef>
+          <a:fillRef idx="3">
+            <a:schemeClr val="accent1"/>
+          </a:fillRef>
+          <a:effectRef idx="2">
+            <a:schemeClr val="accent1"/>
+          </a:effectRef>
+          <a:fontRef idx="minor">
+            <a:schemeClr val="lt1"/>
+          </a:fontRef>
+        </p:style>
+        <p:txBody>
+          <a:bodyPr rtlCol="0" anchor="ctr"/>
+          <a:lstStyle/>
+          <a:p>
+            <a:pPr algn="ctr"/>
+          </a:p>
+        </p:txBody>
+      </p:sp>
+      <p:sp>
+        <p:nvSpPr>
+          <p:cNvPr id="12" name="TextBox 11"/>
           <p:cNvSpPr txBox="1"/>
           <p:nvPr/>
         </p:nvSpPr>
         <p:spPr>
           <a:xfrm>
-            <a:off x="822960" y="1691640"/>
-            <a:ext cx="10241280" cy="4389120"/>
+            <a:off x="2255824" y="1847088"/>
+            <a:ext cx="384048" cy="365760"/>
           </a:xfrm>
           <a:prstGeom prst="rect">
             <a:avLst/>
@@ -3489,83 +3797,305 @@
           <a:noFill/>
         </p:spPr>
         <p:txBody>
-          <a:bodyPr wrap="square" anchor="t">
+          <a:bodyPr wrap="none">
             <a:spAutoFit/>
           </a:bodyPr>
           <a:lstStyle/>
           <a:p>
-            <a:pPr>
+            <a:pPr algn="ctr">
               <a:spcAft>
-                <a:spcPts val="1600"/>
+                <a:spcPts val="1000"/>
               </a:spcAft>
             </a:pPr>
             <a:r>
-              <a:rPr sz="2600" b="1">
+              <a:rPr sz="1600" b="1">
                 <a:solidFill>
-                  <a:srgbClr val="FF7F66"/>
+                  <a:srgbClr val="FFFFFF"/>
                 </a:solidFill>
                 <a:latin typeface="Microsoft YaHei"/>
               </a:rPr>
-              <a:t>目标1  </a:t>
-            </a:r>
-            <a:r>
-              <a:rPr sz="2600" b="0">
+              <a:t>1</a:t>
+            </a:r>
+          </a:p>
+        </p:txBody>
+      </p:sp>
+      <p:sp>
+        <p:nvSpPr>
+          <p:cNvPr id="13" name="TextBox 12"/>
+          <p:cNvSpPr txBox="1"/>
+          <p:nvPr/>
+        </p:nvSpPr>
+        <p:spPr>
+          <a:xfrm>
+            <a:off x="2758744" y="1810512"/>
+            <a:ext cx="7772400" cy="502920"/>
+          </a:xfrm>
+          <a:prstGeom prst="rect">
+            <a:avLst/>
+          </a:prstGeom>
+          <a:noFill/>
+        </p:spPr>
+        <p:txBody>
+          <a:bodyPr wrap="none">
+            <a:spAutoFit/>
+          </a:bodyPr>
+          <a:lstStyle/>
+          <a:p>
+            <a:pPr algn="l">
+              <a:spcAft>
+                <a:spcPts val="1000"/>
+              </a:spcAft>
+            </a:pPr>
+            <a:r>
+              <a:rPr sz="2400" b="0">
                 <a:solidFill>
-                  <a:srgbClr val="5A606E"/>
+                  <a:srgbClr val="502814"/>
                 </a:solidFill>
                 <a:latin typeface="Microsoft YaHei"/>
               </a:rPr>
-              <a:t>梳理孙悟空与二郎神的变化链</a:t>
-            </a:r>
-          </a:p>
-          <a:p>
-            <a:pPr>
+              <a:t>梳理孙悟空与二郎神的变化链，概括故事经过</a:t>
+            </a:r>
+          </a:p>
+        </p:txBody>
+      </p:sp>
+      <p:sp>
+        <p:nvSpPr>
+          <p:cNvPr id="14" name="Oval 13"/>
+          <p:cNvSpPr/>
+          <p:nvPr/>
+        </p:nvSpPr>
+        <p:spPr>
+          <a:xfrm>
+            <a:off x="2255824" y="2395728"/>
+            <a:ext cx="384048" cy="384048"/>
+          </a:xfrm>
+          <a:prstGeom prst="ellipse">
+            <a:avLst/>
+          </a:prstGeom>
+          <a:solidFill>
+            <a:srgbClr val="DC5028"/>
+          </a:solidFill>
+          <a:ln>
+            <a:noFill/>
+          </a:ln>
+        </p:spPr>
+        <p:style>
+          <a:lnRef idx="1">
+            <a:schemeClr val="accent1"/>
+          </a:lnRef>
+          <a:fillRef idx="3">
+            <a:schemeClr val="accent1"/>
+          </a:fillRef>
+          <a:effectRef idx="2">
+            <a:schemeClr val="accent1"/>
+          </a:effectRef>
+          <a:fontRef idx="minor">
+            <a:schemeClr val="lt1"/>
+          </a:fontRef>
+        </p:style>
+        <p:txBody>
+          <a:bodyPr rtlCol="0" anchor="ctr"/>
+          <a:lstStyle/>
+          <a:p>
+            <a:pPr algn="ctr"/>
+          </a:p>
+        </p:txBody>
+      </p:sp>
+      <p:sp>
+        <p:nvSpPr>
+          <p:cNvPr id="15" name="TextBox 14"/>
+          <p:cNvSpPr txBox="1"/>
+          <p:nvPr/>
+        </p:nvSpPr>
+        <p:spPr>
+          <a:xfrm>
+            <a:off x="2255824" y="2414016"/>
+            <a:ext cx="384048" cy="365760"/>
+          </a:xfrm>
+          <a:prstGeom prst="rect">
+            <a:avLst/>
+          </a:prstGeom>
+          <a:noFill/>
+        </p:spPr>
+        <p:txBody>
+          <a:bodyPr wrap="none">
+            <a:spAutoFit/>
+          </a:bodyPr>
+          <a:lstStyle/>
+          <a:p>
+            <a:pPr algn="ctr">
               <a:spcAft>
-                <a:spcPts val="1600"/>
+                <a:spcPts val="1000"/>
               </a:spcAft>
             </a:pPr>
             <a:r>
-              <a:rPr sz="2600" b="1">
+              <a:rPr sz="1600" b="1">
                 <a:solidFill>
-                  <a:srgbClr val="FF7F66"/>
+                  <a:srgbClr val="FFFFFF"/>
                 </a:solidFill>
                 <a:latin typeface="Microsoft YaHei"/>
               </a:rPr>
-              <a:t>目标2  </a:t>
-            </a:r>
-            <a:r>
-              <a:rPr sz="2600" b="0">
+              <a:t>2</a:t>
+            </a:r>
+          </a:p>
+        </p:txBody>
+      </p:sp>
+      <p:sp>
+        <p:nvSpPr>
+          <p:cNvPr id="16" name="TextBox 15"/>
+          <p:cNvSpPr txBox="1"/>
+          <p:nvPr/>
+        </p:nvSpPr>
+        <p:spPr>
+          <a:xfrm>
+            <a:off x="2758744" y="2377440"/>
+            <a:ext cx="7772400" cy="502920"/>
+          </a:xfrm>
+          <a:prstGeom prst="rect">
+            <a:avLst/>
+          </a:prstGeom>
+          <a:noFill/>
+        </p:spPr>
+        <p:txBody>
+          <a:bodyPr wrap="none">
+            <a:spAutoFit/>
+          </a:bodyPr>
+          <a:lstStyle/>
+          <a:p>
+            <a:pPr algn="l">
+              <a:spcAft>
+                <a:spcPts val="1000"/>
+              </a:spcAft>
+            </a:pPr>
+            <a:r>
+              <a:rPr sz="2400" b="0">
                 <a:solidFill>
-                  <a:srgbClr val="5A606E"/>
+                  <a:srgbClr val="502814"/>
                 </a:solidFill>
                 <a:latin typeface="Microsoft YaHei"/>
               </a:rPr>
-              <a:t>分析神魔形象与想象趣味</a:t>
-            </a:r>
-          </a:p>
-          <a:p>
-            <a:pPr>
+              <a:t>分析神魔形象及小说想象的趣味</a:t>
+            </a:r>
+          </a:p>
+        </p:txBody>
+      </p:sp>
+      <p:sp>
+        <p:nvSpPr>
+          <p:cNvPr id="17" name="Oval 16"/>
+          <p:cNvSpPr/>
+          <p:nvPr/>
+        </p:nvSpPr>
+        <p:spPr>
+          <a:xfrm>
+            <a:off x="2255824" y="2962656"/>
+            <a:ext cx="384048" cy="384048"/>
+          </a:xfrm>
+          <a:prstGeom prst="ellipse">
+            <a:avLst/>
+          </a:prstGeom>
+          <a:solidFill>
+            <a:srgbClr val="DC5028"/>
+          </a:solidFill>
+          <a:ln>
+            <a:noFill/>
+          </a:ln>
+        </p:spPr>
+        <p:style>
+          <a:lnRef idx="1">
+            <a:schemeClr val="accent1"/>
+          </a:lnRef>
+          <a:fillRef idx="3">
+            <a:schemeClr val="accent1"/>
+          </a:fillRef>
+          <a:effectRef idx="2">
+            <a:schemeClr val="accent1"/>
+          </a:effectRef>
+          <a:fontRef idx="minor">
+            <a:schemeClr val="lt1"/>
+          </a:fontRef>
+        </p:style>
+        <p:txBody>
+          <a:bodyPr rtlCol="0" anchor="ctr"/>
+          <a:lstStyle/>
+          <a:p>
+            <a:pPr algn="ctr"/>
+          </a:p>
+        </p:txBody>
+      </p:sp>
+      <p:sp>
+        <p:nvSpPr>
+          <p:cNvPr id="18" name="TextBox 17"/>
+          <p:cNvSpPr txBox="1"/>
+          <p:nvPr/>
+        </p:nvSpPr>
+        <p:spPr>
+          <a:xfrm>
+            <a:off x="2255824" y="2980944"/>
+            <a:ext cx="384048" cy="365760"/>
+          </a:xfrm>
+          <a:prstGeom prst="rect">
+            <a:avLst/>
+          </a:prstGeom>
+          <a:noFill/>
+        </p:spPr>
+        <p:txBody>
+          <a:bodyPr wrap="none">
+            <a:spAutoFit/>
+          </a:bodyPr>
+          <a:lstStyle/>
+          <a:p>
+            <a:pPr algn="ctr">
               <a:spcAft>
-                <a:spcPts val="1600"/>
+                <a:spcPts val="1000"/>
               </a:spcAft>
             </a:pPr>
             <a:r>
-              <a:rPr sz="2600" b="1">
+              <a:rPr sz="1600" b="1">
                 <a:solidFill>
-                  <a:srgbClr val="FF7F66"/>
+                  <a:srgbClr val="FFFFFF"/>
                 </a:solidFill>
                 <a:latin typeface="Microsoft YaHei"/>
               </a:rPr>
-              <a:t>目标3  </a:t>
-            </a:r>
-            <a:r>
-              <a:rPr sz="2600" b="0">
+              <a:t>3</a:t>
+            </a:r>
+          </a:p>
+        </p:txBody>
+      </p:sp>
+      <p:sp>
+        <p:nvSpPr>
+          <p:cNvPr id="19" name="TextBox 18"/>
+          <p:cNvSpPr txBox="1"/>
+          <p:nvPr/>
+        </p:nvSpPr>
+        <p:spPr>
+          <a:xfrm>
+            <a:off x="2758744" y="2944368"/>
+            <a:ext cx="7772400" cy="502920"/>
+          </a:xfrm>
+          <a:prstGeom prst="rect">
+            <a:avLst/>
+          </a:prstGeom>
+          <a:noFill/>
+        </p:spPr>
+        <p:txBody>
+          <a:bodyPr wrap="none">
+            <a:spAutoFit/>
+          </a:bodyPr>
+          <a:lstStyle/>
+          <a:p>
+            <a:pPr algn="l">
+              <a:spcAft>
+                <a:spcPts val="1000"/>
+              </a:spcAft>
+            </a:pPr>
+            <a:r>
+              <a:rPr sz="2400" b="0">
                 <a:solidFill>
-                  <a:srgbClr val="5A606E"/>
+                  <a:srgbClr val="502814"/>
                 </a:solidFill>
                 <a:latin typeface="Microsoft YaHei"/>
               </a:rPr>
-              <a:t>探究「自由与规则」母题</a:t>
+              <a:t>探究「自由与规则」母题，提炼策展主题一</a:t>
             </a:r>
           </a:p>
         </p:txBody>
@@ -3620,17 +4150,17 @@
         </p:nvSpPr>
         <p:spPr>
           <a:xfrm>
-            <a:off x="0" y="0"/>
-            <a:ext cx="12191695" cy="6858000"/>
-          </a:xfrm>
-          <a:prstGeom prst="rect">
-            <a:avLst/>
-          </a:prstGeom>
-          <a:solidFill>
-            <a:srgbClr val="FCFAF7"/>
-          </a:solidFill>
-          <a:ln>
-            <a:noFill/>
+            <a:off x="292608" y="274320"/>
+            <a:ext cx="11594592" cy="6300216"/>
+          </a:xfrm>
+          <a:prstGeom prst="rect">
+            <a:avLst/>
+          </a:prstGeom>
+          <a:noFill/>
+          <a:ln w="31750">
+            <a:solidFill>
+              <a:srgbClr val="C85A32"/>
+            </a:solidFill>
           </a:ln>
         </p:spPr>
         <p:style>
@@ -3655,22 +4185,70 @@
           </a:p>
         </p:txBody>
       </p:sp>
-      <p:sp>
-        <p:nvSpPr>
-          <p:cNvPr id="4" name="Rectangle 3"/>
+      <p:pic>
+        <p:nvPicPr>
+          <p:cNvPr id="4" name="Picture 3" descr="corner_wukong_tl.png"/>
+          <p:cNvPicPr>
+            <a:picLocks noChangeAspect="1"/>
+          </p:cNvPicPr>
+          <p:nvPr/>
+        </p:nvPicPr>
+        <p:blipFill>
+          <a:blip r:embed="rId3"/>
+          <a:stretch>
+            <a:fillRect/>
+          </a:stretch>
+        </p:blipFill>
+        <p:spPr>
+          <a:xfrm>
+            <a:off x="-45720" y="-45720"/>
+            <a:ext cx="2011680" cy="2011680"/>
+          </a:xfrm>
+          <a:prstGeom prst="rect">
+            <a:avLst/>
+          </a:prstGeom>
+        </p:spPr>
+      </p:pic>
+      <p:pic>
+        <p:nvPicPr>
+          <p:cNvPr id="5" name="Picture 4" descr="corner_wukong_tr.png"/>
+          <p:cNvPicPr>
+            <a:picLocks noChangeAspect="1"/>
+          </p:cNvPicPr>
+          <p:nvPr/>
+        </p:nvPicPr>
+        <p:blipFill>
+          <a:blip r:embed="rId4"/>
+          <a:stretch>
+            <a:fillRect/>
+          </a:stretch>
+        </p:blipFill>
+        <p:spPr>
+          <a:xfrm>
+            <a:off x="9875520" y="-45720"/>
+            <a:ext cx="2011680" cy="2011680"/>
+          </a:xfrm>
+          <a:prstGeom prst="rect">
+            <a:avLst/>
+          </a:prstGeom>
+        </p:spPr>
+      </p:pic>
+      <p:sp>
+        <p:nvSpPr>
+          <p:cNvPr id="6" name="Rounded Rectangle 5"/>
           <p:cNvSpPr/>
           <p:nvPr/>
         </p:nvSpPr>
         <p:spPr>
           <a:xfrm>
-            <a:off x="0" y="0"/>
-            <a:ext cx="12191695" cy="109728"/>
-          </a:xfrm>
-          <a:prstGeom prst="rect">
+            <a:off x="4953304" y="1005840"/>
+            <a:ext cx="2286000" cy="411480"/>
+          </a:xfrm>
+          <a:prstGeom prst="roundRect">
             <a:avLst/>
           </a:prstGeom>
           <a:solidFill>
-            <a:srgbClr val="FFD166"/>
+            <a:srgbClr val="FFB464"/>
           </a:solidFill>
           <a:ln>
             <a:noFill/>
@@ -3700,14 +4278,53 @@
       </p:sp>
       <p:sp>
         <p:nvSpPr>
-          <p:cNvPr id="5" name="TextBox 4"/>
+          <p:cNvPr id="7" name="TextBox 6"/>
           <p:cNvSpPr txBox="1"/>
           <p:nvPr/>
         </p:nvSpPr>
         <p:spPr>
           <a:xfrm>
-            <a:off x="914400" y="1828800"/>
-            <a:ext cx="10058400" cy="2286000"/>
+            <a:off x="4953304" y="1024128"/>
+            <a:ext cx="2286000" cy="384048"/>
+          </a:xfrm>
+          <a:prstGeom prst="rect">
+            <a:avLst/>
+          </a:prstGeom>
+          <a:noFill/>
+        </p:spPr>
+        <p:txBody>
+          <a:bodyPr wrap="none">
+            <a:spAutoFit/>
+          </a:bodyPr>
+          <a:lstStyle/>
+          <a:p>
+            <a:pPr algn="ctr">
+              <a:spcAft>
+                <a:spcPts val="1000"/>
+              </a:spcAft>
+            </a:pPr>
+            <a:r>
+              <a:rPr sz="1800" b="1">
+                <a:solidFill>
+                  <a:srgbClr val="502814"/>
+                </a:solidFill>
+                <a:latin typeface="Microsoft YaHei"/>
+              </a:rPr>
+              <a:t>想一想</a:t>
+            </a:r>
+          </a:p>
+        </p:txBody>
+      </p:sp>
+      <p:sp>
+        <p:nvSpPr>
+          <p:cNvPr id="8" name="TextBox 7"/>
+          <p:cNvSpPr txBox="1"/>
+          <p:nvPr/>
+        </p:nvSpPr>
+        <p:spPr>
+          <a:xfrm>
+            <a:off x="1371600" y="1600200"/>
+            <a:ext cx="9418320" cy="822960"/>
           </a:xfrm>
           <a:prstGeom prst="rect">
             <a:avLst/>
@@ -3720,46 +4337,76 @@
           </a:bodyPr>
           <a:lstStyle/>
           <a:p>
-            <a:pPr algn="ctr"/>
-            <a:r>
-              <a:rPr sz="3000" b="1">
+            <a:pPr algn="ctr">
+              <a:spcAft>
+                <a:spcPts val="1000"/>
+              </a:spcAft>
+            </a:pPr>
+            <a:r>
+              <a:rPr sz="3200" b="1">
                 <a:solidFill>
-                  <a:srgbClr val="FFD166"/>
+                  <a:srgbClr val="DC5028"/>
                 </a:solidFill>
                 <a:latin typeface="Microsoft YaHei"/>
               </a:rPr>
-              <a:t>💭 想一想</a:t>
-            </a:r>
-          </a:p>
-          <a:p>
-            <a:pPr algn="ctr">
-              <a:spcBef>
-                <a:spcPts val="2000"/>
-              </a:spcBef>
-            </a:pPr>
-            <a:r>
-              <a:rPr sz="3400" b="1">
-                <a:solidFill>
-                  <a:srgbClr val="5A606E"/>
-                </a:solidFill>
-                <a:latin typeface="Microsoft YaHei"/>
-              </a:rPr>
-              <a:t>高手过招，吸引人的不只是
-「谁赢了」——</a:t>
-            </a:r>
-          </a:p>
-        </p:txBody>
-      </p:sp>
-      <p:sp>
-        <p:nvSpPr>
-          <p:cNvPr id="6" name="TextBox 5"/>
+              <a:t>高手过招，吸引人的不只是「谁赢了」</a:t>
+            </a:r>
+          </a:p>
+        </p:txBody>
+      </p:sp>
+      <p:sp>
+        <p:nvSpPr>
+          <p:cNvPr id="9" name="Rectangle 8"/>
+          <p:cNvSpPr/>
+          <p:nvPr/>
+        </p:nvSpPr>
+        <p:spPr>
+          <a:xfrm>
+            <a:off x="3200400" y="4389120"/>
+            <a:ext cx="5760720" cy="27432"/>
+          </a:xfrm>
+          <a:prstGeom prst="rect">
+            <a:avLst/>
+          </a:prstGeom>
+          <a:solidFill>
+            <a:srgbClr val="FFB464"/>
+          </a:solidFill>
+          <a:ln>
+            <a:noFill/>
+          </a:ln>
+        </p:spPr>
+        <p:style>
+          <a:lnRef idx="1">
+            <a:schemeClr val="accent1"/>
+          </a:lnRef>
+          <a:fillRef idx="3">
+            <a:schemeClr val="accent1"/>
+          </a:fillRef>
+          <a:effectRef idx="2">
+            <a:schemeClr val="accent1"/>
+          </a:effectRef>
+          <a:fontRef idx="minor">
+            <a:schemeClr val="lt1"/>
+          </a:fontRef>
+        </p:style>
+        <p:txBody>
+          <a:bodyPr rtlCol="0" anchor="ctr"/>
+          <a:lstStyle/>
+          <a:p>
+            <a:pPr algn="ctr"/>
+          </a:p>
+        </p:txBody>
+      </p:sp>
+      <p:sp>
+        <p:nvSpPr>
+          <p:cNvPr id="10" name="TextBox 9"/>
           <p:cNvSpPr txBox="1"/>
           <p:nvPr/>
         </p:nvSpPr>
         <p:spPr>
           <a:xfrm>
-            <a:off x="1371600" y="4572000"/>
-            <a:ext cx="9144000" cy="1097280"/>
+            <a:off x="1828800" y="4663440"/>
+            <a:ext cx="8503920" cy="914400"/>
           </a:xfrm>
           <a:prstGeom prst="rect">
             <a:avLst/>
@@ -3772,11 +4419,15 @@
           </a:bodyPr>
           <a:lstStyle/>
           <a:p>
-            <a:pPr algn="ctr"/>
-            <a:r>
-              <a:rPr sz="2400" b="0">
+            <a:pPr algn="ctr">
+              <a:spcAft>
+                <a:spcPts val="1000"/>
+              </a:spcAft>
+            </a:pPr>
+            <a:r>
+              <a:rPr sz="2200" b="0">
                 <a:solidFill>
-                  <a:srgbClr val="FFD166"/>
+                  <a:srgbClr val="DC5028"/>
                 </a:solidFill>
                 <a:latin typeface="Microsoft YaHei"/>
               </a:rPr>
@@ -3835,17 +4486,17 @@
         </p:nvSpPr>
         <p:spPr>
           <a:xfrm>
-            <a:off x="0" y="0"/>
-            <a:ext cx="12191695" cy="6858000"/>
-          </a:xfrm>
-          <a:prstGeom prst="rect">
-            <a:avLst/>
-          </a:prstGeom>
-          <a:solidFill>
-            <a:srgbClr val="FCFAF7"/>
-          </a:solidFill>
-          <a:ln>
-            <a:noFill/>
+            <a:off x="292608" y="274320"/>
+            <a:ext cx="11594592" cy="6300216"/>
+          </a:xfrm>
+          <a:prstGeom prst="rect">
+            <a:avLst/>
+          </a:prstGeom>
+          <a:noFill/>
+          <a:ln w="31750">
+            <a:solidFill>
+              <a:srgbClr val="C85A32"/>
+            </a:solidFill>
           </a:ln>
         </p:spPr>
         <p:style>
@@ -3870,22 +4521,70 @@
           </a:p>
         </p:txBody>
       </p:sp>
-      <p:sp>
-        <p:nvSpPr>
-          <p:cNvPr id="4" name="Rectangle 3"/>
+      <p:pic>
+        <p:nvPicPr>
+          <p:cNvPr id="4" name="Picture 3" descr="corner_wukong_tl.png"/>
+          <p:cNvPicPr>
+            <a:picLocks noChangeAspect="1"/>
+          </p:cNvPicPr>
+          <p:nvPr/>
+        </p:nvPicPr>
+        <p:blipFill>
+          <a:blip r:embed="rId3"/>
+          <a:stretch>
+            <a:fillRect/>
+          </a:stretch>
+        </p:blipFill>
+        <p:spPr>
+          <a:xfrm>
+            <a:off x="-45720" y="-45720"/>
+            <a:ext cx="2011680" cy="2011680"/>
+          </a:xfrm>
+          <a:prstGeom prst="rect">
+            <a:avLst/>
+          </a:prstGeom>
+        </p:spPr>
+      </p:pic>
+      <p:pic>
+        <p:nvPicPr>
+          <p:cNvPr id="5" name="Picture 4" descr="corner_wukong_tr.png"/>
+          <p:cNvPicPr>
+            <a:picLocks noChangeAspect="1"/>
+          </p:cNvPicPr>
+          <p:nvPr/>
+        </p:nvPicPr>
+        <p:blipFill>
+          <a:blip r:embed="rId4"/>
+          <a:stretch>
+            <a:fillRect/>
+          </a:stretch>
+        </p:blipFill>
+        <p:spPr>
+          <a:xfrm>
+            <a:off x="9875520" y="-45720"/>
+            <a:ext cx="2011680" cy="2011680"/>
+          </a:xfrm>
+          <a:prstGeom prst="rect">
+            <a:avLst/>
+          </a:prstGeom>
+        </p:spPr>
+      </p:pic>
+      <p:sp>
+        <p:nvSpPr>
+          <p:cNvPr id="6" name="Rounded Rectangle 5"/>
           <p:cNvSpPr/>
           <p:nvPr/>
         </p:nvSpPr>
         <p:spPr>
           <a:xfrm>
-            <a:off x="0" y="0"/>
-            <a:ext cx="12191695" cy="91440"/>
-          </a:xfrm>
-          <a:prstGeom prst="rect">
+            <a:off x="4953304" y="502920"/>
+            <a:ext cx="2286000" cy="411480"/>
+          </a:xfrm>
+          <a:prstGeom prst="roundRect">
             <a:avLst/>
           </a:prstGeom>
           <a:solidFill>
-            <a:srgbClr val="FF7F66"/>
+            <a:srgbClr val="FFB464"/>
           </a:solidFill>
           <a:ln>
             <a:noFill/>
@@ -3915,14 +4614,14 @@
       </p:sp>
       <p:sp>
         <p:nvSpPr>
-          <p:cNvPr id="5" name="TextBox 4"/>
+          <p:cNvPr id="7" name="TextBox 6"/>
           <p:cNvSpPr txBox="1"/>
           <p:nvPr/>
         </p:nvSpPr>
         <p:spPr>
           <a:xfrm>
-            <a:off x="640080" y="228600"/>
-            <a:ext cx="2743200" cy="457200"/>
+            <a:off x="4953304" y="521208"/>
+            <a:ext cx="2286000" cy="384048"/>
           </a:xfrm>
           <a:prstGeom prst="rect">
             <a:avLst/>
@@ -3935,28 +4634,203 @@
           </a:bodyPr>
           <a:lstStyle/>
           <a:p>
-            <a:r>
-              <a:rPr sz="2000" b="1">
+            <a:pPr algn="ctr">
+              <a:spcAft>
+                <a:spcPts val="1000"/>
+              </a:spcAft>
+            </a:pPr>
+            <a:r>
+              <a:rPr sz="1800" b="1">
                 <a:solidFill>
-                  <a:srgbClr val="FF7F66"/>
+                  <a:srgbClr val="502814"/>
                 </a:solidFill>
                 <a:latin typeface="Microsoft YaHei"/>
               </a:rPr>
-              <a:t>以生为主</a:t>
-            </a:r>
-          </a:p>
-        </p:txBody>
-      </p:sp>
-      <p:sp>
-        <p:nvSpPr>
-          <p:cNvPr id="6" name="TextBox 5"/>
+              <a:t>变形追逐图</a:t>
+            </a:r>
+          </a:p>
+        </p:txBody>
+      </p:sp>
+      <p:sp>
+        <p:nvSpPr>
+          <p:cNvPr id="8" name="TextBox 7"/>
           <p:cNvSpPr txBox="1"/>
           <p:nvPr/>
         </p:nvSpPr>
         <p:spPr>
           <a:xfrm>
-            <a:off x="640080" y="685800"/>
-            <a:ext cx="10515600" cy="914400"/>
+            <a:off x="1371600" y="960120"/>
+            <a:ext cx="9418320" cy="822960"/>
+          </a:xfrm>
+          <a:prstGeom prst="rect">
+            <a:avLst/>
+          </a:prstGeom>
+          <a:noFill/>
+        </p:spPr>
+        <p:txBody>
+          <a:bodyPr wrap="square">
+            <a:spAutoFit/>
+          </a:bodyPr>
+          <a:lstStyle/>
+          <a:p>
+            <a:pPr algn="ctr">
+              <a:spcAft>
+                <a:spcPts val="1000"/>
+              </a:spcAft>
+            </a:pPr>
+            <a:r>
+              <a:rPr sz="3600" b="1">
+                <a:solidFill>
+                  <a:srgbClr val="DC5028"/>
+                </a:solidFill>
+                <a:latin typeface="Microsoft YaHei"/>
+              </a:rPr>
+              <a:t>学习任务一</a:t>
+            </a:r>
+          </a:p>
+        </p:txBody>
+      </p:sp>
+      <p:sp>
+        <p:nvSpPr>
+          <p:cNvPr id="9" name="Rectangle 8"/>
+          <p:cNvSpPr/>
+          <p:nvPr/>
+        </p:nvSpPr>
+        <p:spPr>
+          <a:xfrm>
+            <a:off x="3200400" y="1600200"/>
+            <a:ext cx="5760720" cy="27432"/>
+          </a:xfrm>
+          <a:prstGeom prst="rect">
+            <a:avLst/>
+          </a:prstGeom>
+          <a:solidFill>
+            <a:srgbClr val="FFB464"/>
+          </a:solidFill>
+          <a:ln>
+            <a:noFill/>
+          </a:ln>
+        </p:spPr>
+        <p:style>
+          <a:lnRef idx="1">
+            <a:schemeClr val="accent1"/>
+          </a:lnRef>
+          <a:fillRef idx="3">
+            <a:schemeClr val="accent1"/>
+          </a:fillRef>
+          <a:effectRef idx="2">
+            <a:schemeClr val="accent1"/>
+          </a:effectRef>
+          <a:fontRef idx="minor">
+            <a:schemeClr val="lt1"/>
+          </a:fontRef>
+        </p:style>
+        <p:txBody>
+          <a:bodyPr rtlCol="0" anchor="ctr"/>
+          <a:lstStyle/>
+          <a:p>
+            <a:pPr algn="ctr"/>
+          </a:p>
+        </p:txBody>
+      </p:sp>
+      <p:sp>
+        <p:nvSpPr>
+          <p:cNvPr id="10" name="Rounded Rectangle 9"/>
+          <p:cNvSpPr/>
+          <p:nvPr/>
+        </p:nvSpPr>
+        <p:spPr>
+          <a:xfrm>
+            <a:off x="1295704" y="1645920"/>
+            <a:ext cx="9601200" cy="2240280"/>
+          </a:xfrm>
+          <a:prstGeom prst="roundRect">
+            <a:avLst/>
+          </a:prstGeom>
+          <a:solidFill>
+            <a:srgbClr val="FFF8F0"/>
+          </a:solidFill>
+          <a:ln w="19050">
+            <a:solidFill>
+              <a:srgbClr val="FFB464"/>
+            </a:solidFill>
+          </a:ln>
+        </p:spPr>
+        <p:style>
+          <a:lnRef idx="1">
+            <a:schemeClr val="accent1"/>
+          </a:lnRef>
+          <a:fillRef idx="3">
+            <a:schemeClr val="accent1"/>
+          </a:fillRef>
+          <a:effectRef idx="2">
+            <a:schemeClr val="accent1"/>
+          </a:effectRef>
+          <a:fontRef idx="minor">
+            <a:schemeClr val="lt1"/>
+          </a:fontRef>
+        </p:style>
+        <p:txBody>
+          <a:bodyPr rtlCol="0" anchor="ctr"/>
+          <a:lstStyle/>
+          <a:p>
+            <a:pPr algn="ctr"/>
+          </a:p>
+        </p:txBody>
+      </p:sp>
+      <p:sp>
+        <p:nvSpPr>
+          <p:cNvPr id="11" name="Oval 10"/>
+          <p:cNvSpPr/>
+          <p:nvPr/>
+        </p:nvSpPr>
+        <p:spPr>
+          <a:xfrm>
+            <a:off x="2255824" y="1828800"/>
+            <a:ext cx="384048" cy="384048"/>
+          </a:xfrm>
+          <a:prstGeom prst="ellipse">
+            <a:avLst/>
+          </a:prstGeom>
+          <a:solidFill>
+            <a:srgbClr val="DC5028"/>
+          </a:solidFill>
+          <a:ln>
+            <a:noFill/>
+          </a:ln>
+        </p:spPr>
+        <p:style>
+          <a:lnRef idx="1">
+            <a:schemeClr val="accent1"/>
+          </a:lnRef>
+          <a:fillRef idx="3">
+            <a:schemeClr val="accent1"/>
+          </a:fillRef>
+          <a:effectRef idx="2">
+            <a:schemeClr val="accent1"/>
+          </a:effectRef>
+          <a:fontRef idx="minor">
+            <a:schemeClr val="lt1"/>
+          </a:fontRef>
+        </p:style>
+        <p:txBody>
+          <a:bodyPr rtlCol="0" anchor="ctr"/>
+          <a:lstStyle/>
+          <a:p>
+            <a:pPr algn="ctr"/>
+          </a:p>
+        </p:txBody>
+      </p:sp>
+      <p:sp>
+        <p:nvSpPr>
+          <p:cNvPr id="12" name="TextBox 11"/>
+          <p:cNvSpPr txBox="1"/>
+          <p:nvPr/>
+        </p:nvSpPr>
+        <p:spPr>
+          <a:xfrm>
+            <a:off x="2255824" y="1847088"/>
+            <a:ext cx="384048" cy="365760"/>
           </a:xfrm>
           <a:prstGeom prst="rect">
             <a:avLst/>
@@ -3969,28 +4843,33 @@
           </a:bodyPr>
           <a:lstStyle/>
           <a:p>
-            <a:r>
-              <a:rPr sz="3600" b="1">
+            <a:pPr algn="ctr">
+              <a:spcAft>
+                <a:spcPts val="1000"/>
+              </a:spcAft>
+            </a:pPr>
+            <a:r>
+              <a:rPr sz="1600" b="1">
                 <a:solidFill>
-                  <a:srgbClr val="5A606E"/>
+                  <a:srgbClr val="FFFFFF"/>
                 </a:solidFill>
                 <a:latin typeface="Microsoft YaHei"/>
               </a:rPr>
-              <a:t>学习任务一 · 变形追逐图</a:t>
-            </a:r>
-          </a:p>
-        </p:txBody>
-      </p:sp>
-      <p:sp>
-        <p:nvSpPr>
-          <p:cNvPr id="7" name="TextBox 6"/>
+              <a:t>1</a:t>
+            </a:r>
+          </a:p>
+        </p:txBody>
+      </p:sp>
+      <p:sp>
+        <p:nvSpPr>
+          <p:cNvPr id="13" name="TextBox 12"/>
           <p:cNvSpPr txBox="1"/>
           <p:nvPr/>
         </p:nvSpPr>
         <p:spPr>
           <a:xfrm>
-            <a:off x="822960" y="1691640"/>
-            <a:ext cx="10241280" cy="4389120"/>
+            <a:off x="2758744" y="1810512"/>
+            <a:ext cx="7772400" cy="502920"/>
           </a:xfrm>
           <a:prstGeom prst="rect">
             <a:avLst/>
@@ -3998,56 +4877,266 @@
           <a:noFill/>
         </p:spPr>
         <p:txBody>
-          <a:bodyPr wrap="square" anchor="t">
+          <a:bodyPr wrap="none">
             <a:spAutoFit/>
           </a:bodyPr>
           <a:lstStyle/>
           <a:p>
-            <a:pPr>
+            <a:pPr algn="l">
               <a:spcAft>
-                <a:spcPts val="1600"/>
+                <a:spcPts val="1000"/>
               </a:spcAft>
             </a:pPr>
             <a:r>
-              <a:rPr sz="2800" b="0">
+              <a:rPr sz="2400" b="0">
                 <a:solidFill>
-                  <a:srgbClr val="5A606E"/>
+                  <a:srgbClr val="502814"/>
                 </a:solidFill>
                 <a:latin typeface="Microsoft YaHei"/>
               </a:rPr>
-              <a:t>默读课文，圈出每次「变作」对象</a:t>
-            </a:r>
-          </a:p>
-          <a:p>
-            <a:pPr>
+              <a:t>默读课文，圈出每次「变作」对象，标序号</a:t>
+            </a:r>
+          </a:p>
+        </p:txBody>
+      </p:sp>
+      <p:sp>
+        <p:nvSpPr>
+          <p:cNvPr id="14" name="Oval 13"/>
+          <p:cNvSpPr/>
+          <p:nvPr/>
+        </p:nvSpPr>
+        <p:spPr>
+          <a:xfrm>
+            <a:off x="2255824" y="2395728"/>
+            <a:ext cx="384048" cy="384048"/>
+          </a:xfrm>
+          <a:prstGeom prst="ellipse">
+            <a:avLst/>
+          </a:prstGeom>
+          <a:solidFill>
+            <a:srgbClr val="DC5028"/>
+          </a:solidFill>
+          <a:ln>
+            <a:noFill/>
+          </a:ln>
+        </p:spPr>
+        <p:style>
+          <a:lnRef idx="1">
+            <a:schemeClr val="accent1"/>
+          </a:lnRef>
+          <a:fillRef idx="3">
+            <a:schemeClr val="accent1"/>
+          </a:fillRef>
+          <a:effectRef idx="2">
+            <a:schemeClr val="accent1"/>
+          </a:effectRef>
+          <a:fontRef idx="minor">
+            <a:schemeClr val="lt1"/>
+          </a:fontRef>
+        </p:style>
+        <p:txBody>
+          <a:bodyPr rtlCol="0" anchor="ctr"/>
+          <a:lstStyle/>
+          <a:p>
+            <a:pPr algn="ctr"/>
+          </a:p>
+        </p:txBody>
+      </p:sp>
+      <p:sp>
+        <p:nvSpPr>
+          <p:cNvPr id="15" name="TextBox 14"/>
+          <p:cNvSpPr txBox="1"/>
+          <p:nvPr/>
+        </p:nvSpPr>
+        <p:spPr>
+          <a:xfrm>
+            <a:off x="2255824" y="2414016"/>
+            <a:ext cx="384048" cy="365760"/>
+          </a:xfrm>
+          <a:prstGeom prst="rect">
+            <a:avLst/>
+          </a:prstGeom>
+          <a:noFill/>
+        </p:spPr>
+        <p:txBody>
+          <a:bodyPr wrap="none">
+            <a:spAutoFit/>
+          </a:bodyPr>
+          <a:lstStyle/>
+          <a:p>
+            <a:pPr algn="ctr">
               <a:spcAft>
-                <a:spcPts val="1600"/>
+                <a:spcPts val="1000"/>
               </a:spcAft>
             </a:pPr>
             <a:r>
-              <a:rPr sz="2800" b="0">
+              <a:rPr sz="1600" b="1">
                 <a:solidFill>
-                  <a:srgbClr val="5A606E"/>
+                  <a:srgbClr val="FFFFFF"/>
                 </a:solidFill>
                 <a:latin typeface="Microsoft YaHei"/>
               </a:rPr>
-              <a:t>填写七十二变对照表</a:t>
-            </a:r>
-          </a:p>
-          <a:p>
-            <a:pPr>
+              <a:t>2</a:t>
+            </a:r>
+          </a:p>
+        </p:txBody>
+      </p:sp>
+      <p:sp>
+        <p:nvSpPr>
+          <p:cNvPr id="16" name="TextBox 15"/>
+          <p:cNvSpPr txBox="1"/>
+          <p:nvPr/>
+        </p:nvSpPr>
+        <p:spPr>
+          <a:xfrm>
+            <a:off x="2758744" y="2377440"/>
+            <a:ext cx="7772400" cy="502920"/>
+          </a:xfrm>
+          <a:prstGeom prst="rect">
+            <a:avLst/>
+          </a:prstGeom>
+          <a:noFill/>
+        </p:spPr>
+        <p:txBody>
+          <a:bodyPr wrap="none">
+            <a:spAutoFit/>
+          </a:bodyPr>
+          <a:lstStyle/>
+          <a:p>
+            <a:pPr algn="l">
               <a:spcAft>
-                <a:spcPts val="1600"/>
+                <a:spcPts val="1000"/>
               </a:spcAft>
             </a:pPr>
             <a:r>
-              <a:rPr sz="2800" b="0">
+              <a:rPr sz="2400" b="0">
                 <a:solidFill>
-                  <a:srgbClr val="5A606E"/>
+                  <a:srgbClr val="502814"/>
                 </a:solidFill>
                 <a:latin typeface="Microsoft YaHei"/>
               </a:rPr>
-              <a:t>用句式复述最精彩一轮（≤40字）</a:t>
+              <a:t>填写七十二变对照表（孙悟空先变—二郎神相克）</a:t>
+            </a:r>
+          </a:p>
+        </p:txBody>
+      </p:sp>
+      <p:sp>
+        <p:nvSpPr>
+          <p:cNvPr id="17" name="Oval 16"/>
+          <p:cNvSpPr/>
+          <p:nvPr/>
+        </p:nvSpPr>
+        <p:spPr>
+          <a:xfrm>
+            <a:off x="2255824" y="2962656"/>
+            <a:ext cx="384048" cy="384048"/>
+          </a:xfrm>
+          <a:prstGeom prst="ellipse">
+            <a:avLst/>
+          </a:prstGeom>
+          <a:solidFill>
+            <a:srgbClr val="DC5028"/>
+          </a:solidFill>
+          <a:ln>
+            <a:noFill/>
+          </a:ln>
+        </p:spPr>
+        <p:style>
+          <a:lnRef idx="1">
+            <a:schemeClr val="accent1"/>
+          </a:lnRef>
+          <a:fillRef idx="3">
+            <a:schemeClr val="accent1"/>
+          </a:fillRef>
+          <a:effectRef idx="2">
+            <a:schemeClr val="accent1"/>
+          </a:effectRef>
+          <a:fontRef idx="minor">
+            <a:schemeClr val="lt1"/>
+          </a:fontRef>
+        </p:style>
+        <p:txBody>
+          <a:bodyPr rtlCol="0" anchor="ctr"/>
+          <a:lstStyle/>
+          <a:p>
+            <a:pPr algn="ctr"/>
+          </a:p>
+        </p:txBody>
+      </p:sp>
+      <p:sp>
+        <p:nvSpPr>
+          <p:cNvPr id="18" name="TextBox 17"/>
+          <p:cNvSpPr txBox="1"/>
+          <p:nvPr/>
+        </p:nvSpPr>
+        <p:spPr>
+          <a:xfrm>
+            <a:off x="2255824" y="2980944"/>
+            <a:ext cx="384048" cy="365760"/>
+          </a:xfrm>
+          <a:prstGeom prst="rect">
+            <a:avLst/>
+          </a:prstGeom>
+          <a:noFill/>
+        </p:spPr>
+        <p:txBody>
+          <a:bodyPr wrap="none">
+            <a:spAutoFit/>
+          </a:bodyPr>
+          <a:lstStyle/>
+          <a:p>
+            <a:pPr algn="ctr">
+              <a:spcAft>
+                <a:spcPts val="1000"/>
+              </a:spcAft>
+            </a:pPr>
+            <a:r>
+              <a:rPr sz="1600" b="1">
+                <a:solidFill>
+                  <a:srgbClr val="FFFFFF"/>
+                </a:solidFill>
+                <a:latin typeface="Microsoft YaHei"/>
+              </a:rPr>
+              <a:t>3</a:t>
+            </a:r>
+          </a:p>
+        </p:txBody>
+      </p:sp>
+      <p:sp>
+        <p:nvSpPr>
+          <p:cNvPr id="19" name="TextBox 18"/>
+          <p:cNvSpPr txBox="1"/>
+          <p:nvPr/>
+        </p:nvSpPr>
+        <p:spPr>
+          <a:xfrm>
+            <a:off x="2758744" y="2944368"/>
+            <a:ext cx="7772400" cy="502920"/>
+          </a:xfrm>
+          <a:prstGeom prst="rect">
+            <a:avLst/>
+          </a:prstGeom>
+          <a:noFill/>
+        </p:spPr>
+        <p:txBody>
+          <a:bodyPr wrap="none">
+            <a:spAutoFit/>
+          </a:bodyPr>
+          <a:lstStyle/>
+          <a:p>
+            <a:pPr algn="l">
+              <a:spcAft>
+                <a:spcPts val="1000"/>
+              </a:spcAft>
+            </a:pPr>
+            <a:r>
+              <a:rPr sz="2400" b="0">
+                <a:solidFill>
+                  <a:srgbClr val="502814"/>
+                </a:solidFill>
+                <a:latin typeface="Microsoft YaHei"/>
+              </a:rPr>
+              <a:t>用「孙悟空先……，二郎神便……」复述最精彩一轮</a:t>
             </a:r>
           </a:p>
         </p:txBody>
@@ -4102,17 +5191,17 @@
         </p:nvSpPr>
         <p:spPr>
           <a:xfrm>
-            <a:off x="0" y="0"/>
-            <a:ext cx="12191695" cy="6858000"/>
-          </a:xfrm>
-          <a:prstGeom prst="rect">
-            <a:avLst/>
-          </a:prstGeom>
-          <a:solidFill>
-            <a:srgbClr val="FCFAF7"/>
-          </a:solidFill>
-          <a:ln>
-            <a:noFill/>
+            <a:off x="292608" y="274320"/>
+            <a:ext cx="11594592" cy="6300216"/>
+          </a:xfrm>
+          <a:prstGeom prst="rect">
+            <a:avLst/>
+          </a:prstGeom>
+          <a:noFill/>
+          <a:ln w="31750">
+            <a:solidFill>
+              <a:srgbClr val="C85A32"/>
+            </a:solidFill>
           </a:ln>
         </p:spPr>
         <p:style>
@@ -4137,22 +5226,70 @@
           </a:p>
         </p:txBody>
       </p:sp>
-      <p:sp>
-        <p:nvSpPr>
-          <p:cNvPr id="4" name="Rectangle 3"/>
+      <p:pic>
+        <p:nvPicPr>
+          <p:cNvPr id="4" name="Picture 3" descr="corner_wukong_tl.png"/>
+          <p:cNvPicPr>
+            <a:picLocks noChangeAspect="1"/>
+          </p:cNvPicPr>
+          <p:nvPr/>
+        </p:nvPicPr>
+        <p:blipFill>
+          <a:blip r:embed="rId3"/>
+          <a:stretch>
+            <a:fillRect/>
+          </a:stretch>
+        </p:blipFill>
+        <p:spPr>
+          <a:xfrm>
+            <a:off x="-45720" y="-45720"/>
+            <a:ext cx="2011680" cy="2011680"/>
+          </a:xfrm>
+          <a:prstGeom prst="rect">
+            <a:avLst/>
+          </a:prstGeom>
+        </p:spPr>
+      </p:pic>
+      <p:pic>
+        <p:nvPicPr>
+          <p:cNvPr id="5" name="Picture 4" descr="corner_wukong_tr.png"/>
+          <p:cNvPicPr>
+            <a:picLocks noChangeAspect="1"/>
+          </p:cNvPicPr>
+          <p:nvPr/>
+        </p:nvPicPr>
+        <p:blipFill>
+          <a:blip r:embed="rId4"/>
+          <a:stretch>
+            <a:fillRect/>
+          </a:stretch>
+        </p:blipFill>
+        <p:spPr>
+          <a:xfrm>
+            <a:off x="9875520" y="-45720"/>
+            <a:ext cx="2011680" cy="2011680"/>
+          </a:xfrm>
+          <a:prstGeom prst="rect">
+            <a:avLst/>
+          </a:prstGeom>
+        </p:spPr>
+      </p:pic>
+      <p:sp>
+        <p:nvSpPr>
+          <p:cNvPr id="6" name="Rounded Rectangle 5"/>
           <p:cNvSpPr/>
           <p:nvPr/>
         </p:nvSpPr>
         <p:spPr>
           <a:xfrm>
-            <a:off x="0" y="0"/>
-            <a:ext cx="12191695" cy="91440"/>
-          </a:xfrm>
-          <a:prstGeom prst="rect">
+            <a:off x="4953304" y="502920"/>
+            <a:ext cx="2286000" cy="411480"/>
+          </a:xfrm>
+          <a:prstGeom prst="roundRect">
             <a:avLst/>
           </a:prstGeom>
           <a:solidFill>
-            <a:srgbClr val="66CDAA"/>
+            <a:srgbClr val="FFB464"/>
           </a:solidFill>
           <a:ln>
             <a:noFill/>
@@ -4182,14 +5319,14 @@
       </p:sp>
       <p:sp>
         <p:nvSpPr>
-          <p:cNvPr id="5" name="TextBox 4"/>
+          <p:cNvPr id="7" name="TextBox 6"/>
           <p:cNvSpPr txBox="1"/>
           <p:nvPr/>
         </p:nvSpPr>
         <p:spPr>
           <a:xfrm>
-            <a:off x="640080" y="228600"/>
-            <a:ext cx="2743200" cy="457200"/>
+            <a:off x="4953304" y="521208"/>
+            <a:ext cx="2286000" cy="384048"/>
           </a:xfrm>
           <a:prstGeom prst="rect">
             <a:avLst/>
@@ -4202,28 +5339,203 @@
           </a:bodyPr>
           <a:lstStyle/>
           <a:p>
-            <a:r>
-              <a:rPr sz="2000" b="1">
+            <a:pPr algn="ctr">
+              <a:spcAft>
+                <a:spcPts val="1000"/>
+              </a:spcAft>
+            </a:pPr>
+            <a:r>
+              <a:rPr sz="1800" b="1">
                 <a:solidFill>
-                  <a:srgbClr val="66CDAA"/>
+                  <a:srgbClr val="502814"/>
                 </a:solidFill>
                 <a:latin typeface="Microsoft YaHei"/>
               </a:rPr>
-              <a:t>细读品味</a:t>
-            </a:r>
-          </a:p>
-        </p:txBody>
-      </p:sp>
-      <p:sp>
-        <p:nvSpPr>
-          <p:cNvPr id="6" name="TextBox 5"/>
+              <a:t>加解说词</a:t>
+            </a:r>
+          </a:p>
+        </p:txBody>
+      </p:sp>
+      <p:sp>
+        <p:nvSpPr>
+          <p:cNvPr id="8" name="TextBox 7"/>
           <p:cNvSpPr txBox="1"/>
           <p:nvPr/>
         </p:nvSpPr>
         <p:spPr>
           <a:xfrm>
-            <a:off x="640080" y="685800"/>
-            <a:ext cx="10515600" cy="914400"/>
+            <a:off x="1371600" y="960120"/>
+            <a:ext cx="9418320" cy="822960"/>
+          </a:xfrm>
+          <a:prstGeom prst="rect">
+            <a:avLst/>
+          </a:prstGeom>
+          <a:noFill/>
+        </p:spPr>
+        <p:txBody>
+          <a:bodyPr wrap="square">
+            <a:spAutoFit/>
+          </a:bodyPr>
+          <a:lstStyle/>
+          <a:p>
+            <a:pPr algn="ctr">
+              <a:spcAft>
+                <a:spcPts val="1000"/>
+              </a:spcAft>
+            </a:pPr>
+            <a:r>
+              <a:rPr sz="3600" b="1">
+                <a:solidFill>
+                  <a:srgbClr val="DC5028"/>
+                </a:solidFill>
+                <a:latin typeface="Microsoft YaHei"/>
+              </a:rPr>
+              <a:t>学习任务二</a:t>
+            </a:r>
+          </a:p>
+        </p:txBody>
+      </p:sp>
+      <p:sp>
+        <p:nvSpPr>
+          <p:cNvPr id="9" name="Rectangle 8"/>
+          <p:cNvSpPr/>
+          <p:nvPr/>
+        </p:nvSpPr>
+        <p:spPr>
+          <a:xfrm>
+            <a:off x="3200400" y="1600200"/>
+            <a:ext cx="5760720" cy="27432"/>
+          </a:xfrm>
+          <a:prstGeom prst="rect">
+            <a:avLst/>
+          </a:prstGeom>
+          <a:solidFill>
+            <a:srgbClr val="FFB464"/>
+          </a:solidFill>
+          <a:ln>
+            <a:noFill/>
+          </a:ln>
+        </p:spPr>
+        <p:style>
+          <a:lnRef idx="1">
+            <a:schemeClr val="accent1"/>
+          </a:lnRef>
+          <a:fillRef idx="3">
+            <a:schemeClr val="accent1"/>
+          </a:fillRef>
+          <a:effectRef idx="2">
+            <a:schemeClr val="accent1"/>
+          </a:effectRef>
+          <a:fontRef idx="minor">
+            <a:schemeClr val="lt1"/>
+          </a:fontRef>
+        </p:style>
+        <p:txBody>
+          <a:bodyPr rtlCol="0" anchor="ctr"/>
+          <a:lstStyle/>
+          <a:p>
+            <a:pPr algn="ctr"/>
+          </a:p>
+        </p:txBody>
+      </p:sp>
+      <p:sp>
+        <p:nvSpPr>
+          <p:cNvPr id="10" name="Rounded Rectangle 9"/>
+          <p:cNvSpPr/>
+          <p:nvPr/>
+        </p:nvSpPr>
+        <p:spPr>
+          <a:xfrm>
+            <a:off x="1295704" y="1645920"/>
+            <a:ext cx="9601200" cy="2240280"/>
+          </a:xfrm>
+          <a:prstGeom prst="roundRect">
+            <a:avLst/>
+          </a:prstGeom>
+          <a:solidFill>
+            <a:srgbClr val="FFF8F0"/>
+          </a:solidFill>
+          <a:ln w="19050">
+            <a:solidFill>
+              <a:srgbClr val="FFB464"/>
+            </a:solidFill>
+          </a:ln>
+        </p:spPr>
+        <p:style>
+          <a:lnRef idx="1">
+            <a:schemeClr val="accent1"/>
+          </a:lnRef>
+          <a:fillRef idx="3">
+            <a:schemeClr val="accent1"/>
+          </a:fillRef>
+          <a:effectRef idx="2">
+            <a:schemeClr val="accent1"/>
+          </a:effectRef>
+          <a:fontRef idx="minor">
+            <a:schemeClr val="lt1"/>
+          </a:fontRef>
+        </p:style>
+        <p:txBody>
+          <a:bodyPr rtlCol="0" anchor="ctr"/>
+          <a:lstStyle/>
+          <a:p>
+            <a:pPr algn="ctr"/>
+          </a:p>
+        </p:txBody>
+      </p:sp>
+      <p:sp>
+        <p:nvSpPr>
+          <p:cNvPr id="11" name="Oval 10"/>
+          <p:cNvSpPr/>
+          <p:nvPr/>
+        </p:nvSpPr>
+        <p:spPr>
+          <a:xfrm>
+            <a:off x="2255824" y="1828800"/>
+            <a:ext cx="384048" cy="384048"/>
+          </a:xfrm>
+          <a:prstGeom prst="ellipse">
+            <a:avLst/>
+          </a:prstGeom>
+          <a:solidFill>
+            <a:srgbClr val="DC5028"/>
+          </a:solidFill>
+          <a:ln>
+            <a:noFill/>
+          </a:ln>
+        </p:spPr>
+        <p:style>
+          <a:lnRef idx="1">
+            <a:schemeClr val="accent1"/>
+          </a:lnRef>
+          <a:fillRef idx="3">
+            <a:schemeClr val="accent1"/>
+          </a:fillRef>
+          <a:effectRef idx="2">
+            <a:schemeClr val="accent1"/>
+          </a:effectRef>
+          <a:fontRef idx="minor">
+            <a:schemeClr val="lt1"/>
+          </a:fontRef>
+        </p:style>
+        <p:txBody>
+          <a:bodyPr rtlCol="0" anchor="ctr"/>
+          <a:lstStyle/>
+          <a:p>
+            <a:pPr algn="ctr"/>
+          </a:p>
+        </p:txBody>
+      </p:sp>
+      <p:sp>
+        <p:nvSpPr>
+          <p:cNvPr id="12" name="TextBox 11"/>
+          <p:cNvSpPr txBox="1"/>
+          <p:nvPr/>
+        </p:nvSpPr>
+        <p:spPr>
+          <a:xfrm>
+            <a:off x="2255824" y="1847088"/>
+            <a:ext cx="384048" cy="365760"/>
           </a:xfrm>
           <a:prstGeom prst="rect">
             <a:avLst/>
@@ -4236,28 +5548,33 @@
           </a:bodyPr>
           <a:lstStyle/>
           <a:p>
-            <a:r>
-              <a:rPr sz="3600" b="1">
+            <a:pPr algn="ctr">
+              <a:spcAft>
+                <a:spcPts val="1000"/>
+              </a:spcAft>
+            </a:pPr>
+            <a:r>
+              <a:rPr sz="1600" b="1">
                 <a:solidFill>
-                  <a:srgbClr val="5A606E"/>
+                  <a:srgbClr val="FFFFFF"/>
                 </a:solidFill>
                 <a:latin typeface="Microsoft YaHei"/>
               </a:rPr>
-              <a:t>学习任务二 · 加解说词</a:t>
-            </a:r>
-          </a:p>
-        </p:txBody>
-      </p:sp>
-      <p:sp>
-        <p:nvSpPr>
-          <p:cNvPr id="7" name="TextBox 6"/>
+              <a:t>1</a:t>
+            </a:r>
+          </a:p>
+        </p:txBody>
+      </p:sp>
+      <p:sp>
+        <p:nvSpPr>
+          <p:cNvPr id="13" name="TextBox 12"/>
           <p:cNvSpPr txBox="1"/>
           <p:nvPr/>
         </p:nvSpPr>
         <p:spPr>
           <a:xfrm>
-            <a:off x="822960" y="1691640"/>
-            <a:ext cx="10241280" cy="4389120"/>
+            <a:off x="2758744" y="1810512"/>
+            <a:ext cx="7772400" cy="502920"/>
           </a:xfrm>
           <a:prstGeom prst="rect">
             <a:avLst/>
@@ -4265,56 +5582,266 @@
           <a:noFill/>
         </p:spPr>
         <p:txBody>
-          <a:bodyPr wrap="square" anchor="t">
+          <a:bodyPr wrap="none">
             <a:spAutoFit/>
           </a:bodyPr>
           <a:lstStyle/>
           <a:p>
-            <a:pPr>
+            <a:pPr algn="l">
               <a:spcAft>
-                <a:spcPts val="1600"/>
+                <a:spcPts val="1000"/>
               </a:spcAft>
             </a:pPr>
             <a:r>
-              <a:rPr sz="2800" b="0">
+              <a:rPr sz="2400" b="0">
                 <a:solidFill>
-                  <a:srgbClr val="5A606E"/>
+                  <a:srgbClr val="502814"/>
                 </a:solidFill>
                 <a:latin typeface="Microsoft YaHei"/>
               </a:rPr>
-              <a:t>变庙宇：尾巴为何变旗竿？</a:t>
-            </a:r>
-          </a:p>
-          <a:p>
-            <a:pPr>
+              <a:t>变庙宇：尾巴为何变旗竿？写一句批注</a:t>
+            </a:r>
+          </a:p>
+        </p:txBody>
+      </p:sp>
+      <p:sp>
+        <p:nvSpPr>
+          <p:cNvPr id="14" name="Oval 13"/>
+          <p:cNvSpPr/>
+          <p:nvPr/>
+        </p:nvSpPr>
+        <p:spPr>
+          <a:xfrm>
+            <a:off x="2255824" y="2395728"/>
+            <a:ext cx="384048" cy="384048"/>
+          </a:xfrm>
+          <a:prstGeom prst="ellipse">
+            <a:avLst/>
+          </a:prstGeom>
+          <a:solidFill>
+            <a:srgbClr val="DC5028"/>
+          </a:solidFill>
+          <a:ln>
+            <a:noFill/>
+          </a:ln>
+        </p:spPr>
+        <p:style>
+          <a:lnRef idx="1">
+            <a:schemeClr val="accent1"/>
+          </a:lnRef>
+          <a:fillRef idx="3">
+            <a:schemeClr val="accent1"/>
+          </a:fillRef>
+          <a:effectRef idx="2">
+            <a:schemeClr val="accent1"/>
+          </a:effectRef>
+          <a:fontRef idx="minor">
+            <a:schemeClr val="lt1"/>
+          </a:fontRef>
+        </p:style>
+        <p:txBody>
+          <a:bodyPr rtlCol="0" anchor="ctr"/>
+          <a:lstStyle/>
+          <a:p>
+            <a:pPr algn="ctr"/>
+          </a:p>
+        </p:txBody>
+      </p:sp>
+      <p:sp>
+        <p:nvSpPr>
+          <p:cNvPr id="15" name="TextBox 14"/>
+          <p:cNvSpPr txBox="1"/>
+          <p:nvPr/>
+        </p:nvSpPr>
+        <p:spPr>
+          <a:xfrm>
+            <a:off x="2255824" y="2414016"/>
+            <a:ext cx="384048" cy="365760"/>
+          </a:xfrm>
+          <a:prstGeom prst="rect">
+            <a:avLst/>
+          </a:prstGeom>
+          <a:noFill/>
+        </p:spPr>
+        <p:txBody>
+          <a:bodyPr wrap="none">
+            <a:spAutoFit/>
+          </a:bodyPr>
+          <a:lstStyle/>
+          <a:p>
+            <a:pPr algn="ctr">
               <a:spcAft>
-                <a:spcPts val="1600"/>
+                <a:spcPts val="1000"/>
               </a:spcAft>
             </a:pPr>
             <a:r>
-              <a:rPr sz="2800" b="0">
+              <a:rPr sz="1600" b="1">
                 <a:solidFill>
-                  <a:srgbClr val="5A606E"/>
+                  <a:srgbClr val="FFFFFF"/>
+                </a:solidFill>
+                <a:latin typeface="Microsoft YaHei"/>
+              </a:rPr>
+              <a:t>2</a:t>
+            </a:r>
+          </a:p>
+        </p:txBody>
+      </p:sp>
+      <p:sp>
+        <p:nvSpPr>
+          <p:cNvPr id="16" name="TextBox 15"/>
+          <p:cNvSpPr txBox="1"/>
+          <p:nvPr/>
+        </p:nvSpPr>
+        <p:spPr>
+          <a:xfrm>
+            <a:off x="2758744" y="2377440"/>
+            <a:ext cx="7772400" cy="502920"/>
+          </a:xfrm>
+          <a:prstGeom prst="rect">
+            <a:avLst/>
+          </a:prstGeom>
+          <a:noFill/>
+        </p:spPr>
+        <p:txBody>
+          <a:bodyPr wrap="none">
+            <a:spAutoFit/>
+          </a:bodyPr>
+          <a:lstStyle/>
+          <a:p>
+            <a:pPr algn="l">
+              <a:spcAft>
+                <a:spcPts val="1000"/>
+              </a:spcAft>
+            </a:pPr>
+            <a:r>
+              <a:rPr sz="2400" b="0">
+                <a:solidFill>
+                  <a:srgbClr val="502814"/>
                 </a:solidFill>
                 <a:latin typeface="Microsoft YaHei"/>
               </a:rPr>
               <a:t>完成人物档案卡（证据—特点—作用）</a:t>
             </a:r>
           </a:p>
-          <a:p>
-            <a:pPr>
+        </p:txBody>
+      </p:sp>
+      <p:sp>
+        <p:nvSpPr>
+          <p:cNvPr id="17" name="Oval 16"/>
+          <p:cNvSpPr/>
+          <p:nvPr/>
+        </p:nvSpPr>
+        <p:spPr>
+          <a:xfrm>
+            <a:off x="2255824" y="2962656"/>
+            <a:ext cx="384048" cy="384048"/>
+          </a:xfrm>
+          <a:prstGeom prst="ellipse">
+            <a:avLst/>
+          </a:prstGeom>
+          <a:solidFill>
+            <a:srgbClr val="DC5028"/>
+          </a:solidFill>
+          <a:ln>
+            <a:noFill/>
+          </a:ln>
+        </p:spPr>
+        <p:style>
+          <a:lnRef idx="1">
+            <a:schemeClr val="accent1"/>
+          </a:lnRef>
+          <a:fillRef idx="3">
+            <a:schemeClr val="accent1"/>
+          </a:fillRef>
+          <a:effectRef idx="2">
+            <a:schemeClr val="accent1"/>
+          </a:effectRef>
+          <a:fontRef idx="minor">
+            <a:schemeClr val="lt1"/>
+          </a:fontRef>
+        </p:style>
+        <p:txBody>
+          <a:bodyPr rtlCol="0" anchor="ctr"/>
+          <a:lstStyle/>
+          <a:p>
+            <a:pPr algn="ctr"/>
+          </a:p>
+        </p:txBody>
+      </p:sp>
+      <p:sp>
+        <p:nvSpPr>
+          <p:cNvPr id="18" name="TextBox 17"/>
+          <p:cNvSpPr txBox="1"/>
+          <p:nvPr/>
+        </p:nvSpPr>
+        <p:spPr>
+          <a:xfrm>
+            <a:off x="2255824" y="2980944"/>
+            <a:ext cx="384048" cy="365760"/>
+          </a:xfrm>
+          <a:prstGeom prst="rect">
+            <a:avLst/>
+          </a:prstGeom>
+          <a:noFill/>
+        </p:spPr>
+        <p:txBody>
+          <a:bodyPr wrap="none">
+            <a:spAutoFit/>
+          </a:bodyPr>
+          <a:lstStyle/>
+          <a:p>
+            <a:pPr algn="ctr">
               <a:spcAft>
-                <a:spcPts val="1600"/>
+                <a:spcPts val="1000"/>
               </a:spcAft>
             </a:pPr>
             <a:r>
-              <a:rPr sz="2800" b="0">
+              <a:rPr sz="1600" b="1">
                 <a:solidFill>
-                  <a:srgbClr val="5A606E"/>
+                  <a:srgbClr val="FFFFFF"/>
                 </a:solidFill>
                 <a:latin typeface="Microsoft YaHei"/>
               </a:rPr>
-              <a:t>批注鲁迅、林庚的评论</a:t>
+              <a:t>3</a:t>
+            </a:r>
+          </a:p>
+        </p:txBody>
+      </p:sp>
+      <p:sp>
+        <p:nvSpPr>
+          <p:cNvPr id="19" name="TextBox 18"/>
+          <p:cNvSpPr txBox="1"/>
+          <p:nvPr/>
+        </p:nvSpPr>
+        <p:spPr>
+          <a:xfrm>
+            <a:off x="2758744" y="2944368"/>
+            <a:ext cx="7772400" cy="502920"/>
+          </a:xfrm>
+          <a:prstGeom prst="rect">
+            <a:avLst/>
+          </a:prstGeom>
+          <a:noFill/>
+        </p:spPr>
+        <p:txBody>
+          <a:bodyPr wrap="none">
+            <a:spAutoFit/>
+          </a:bodyPr>
+          <a:lstStyle/>
+          <a:p>
+            <a:pPr algn="l">
+              <a:spcAft>
+                <a:spcPts val="1000"/>
+              </a:spcAft>
+            </a:pPr>
+            <a:r>
+              <a:rPr sz="2400" b="0">
+                <a:solidFill>
+                  <a:srgbClr val="502814"/>
+                </a:solidFill>
+                <a:latin typeface="Microsoft YaHei"/>
+              </a:rPr>
+              <a:t>批注鲁迅、林庚的评论，找「人情」与「世故」</a:t>
             </a:r>
           </a:p>
         </p:txBody>
@@ -4369,17 +5896,17 @@
         </p:nvSpPr>
         <p:spPr>
           <a:xfrm>
-            <a:off x="0" y="0"/>
-            <a:ext cx="12191695" cy="6858000"/>
-          </a:xfrm>
-          <a:prstGeom prst="rect">
-            <a:avLst/>
-          </a:prstGeom>
-          <a:solidFill>
-            <a:srgbClr val="FCFAF7"/>
-          </a:solidFill>
-          <a:ln>
-            <a:noFill/>
+            <a:off x="292608" y="274320"/>
+            <a:ext cx="11594592" cy="6300216"/>
+          </a:xfrm>
+          <a:prstGeom prst="rect">
+            <a:avLst/>
+          </a:prstGeom>
+          <a:noFill/>
+          <a:ln w="31750">
+            <a:solidFill>
+              <a:srgbClr val="C85A32"/>
+            </a:solidFill>
           </a:ln>
         </p:spPr>
         <p:style>
@@ -4404,22 +5931,70 @@
           </a:p>
         </p:txBody>
       </p:sp>
-      <p:sp>
-        <p:nvSpPr>
-          <p:cNvPr id="4" name="Rectangle 3"/>
+      <p:pic>
+        <p:nvPicPr>
+          <p:cNvPr id="4" name="Picture 3" descr="corner_wukong_tl.png"/>
+          <p:cNvPicPr>
+            <a:picLocks noChangeAspect="1"/>
+          </p:cNvPicPr>
+          <p:nvPr/>
+        </p:nvPicPr>
+        <p:blipFill>
+          <a:blip r:embed="rId3"/>
+          <a:stretch>
+            <a:fillRect/>
+          </a:stretch>
+        </p:blipFill>
+        <p:spPr>
+          <a:xfrm>
+            <a:off x="-45720" y="-45720"/>
+            <a:ext cx="2011680" cy="2011680"/>
+          </a:xfrm>
+          <a:prstGeom prst="rect">
+            <a:avLst/>
+          </a:prstGeom>
+        </p:spPr>
+      </p:pic>
+      <p:pic>
+        <p:nvPicPr>
+          <p:cNvPr id="5" name="Picture 4" descr="corner_wukong_tr.png"/>
+          <p:cNvPicPr>
+            <a:picLocks noChangeAspect="1"/>
+          </p:cNvPicPr>
+          <p:nvPr/>
+        </p:nvPicPr>
+        <p:blipFill>
+          <a:blip r:embed="rId4"/>
+          <a:stretch>
+            <a:fillRect/>
+          </a:stretch>
+        </p:blipFill>
+        <p:spPr>
+          <a:xfrm>
+            <a:off x="9875520" y="-45720"/>
+            <a:ext cx="2011680" cy="2011680"/>
+          </a:xfrm>
+          <a:prstGeom prst="rect">
+            <a:avLst/>
+          </a:prstGeom>
+        </p:spPr>
+      </p:pic>
+      <p:sp>
+        <p:nvSpPr>
+          <p:cNvPr id="6" name="Rounded Rectangle 5"/>
           <p:cNvSpPr/>
           <p:nvPr/>
         </p:nvSpPr>
         <p:spPr>
           <a:xfrm>
-            <a:off x="0" y="0"/>
-            <a:ext cx="12191695" cy="109728"/>
-          </a:xfrm>
-          <a:prstGeom prst="rect">
+            <a:off x="4953304" y="1005840"/>
+            <a:ext cx="2286000" cy="411480"/>
+          </a:xfrm>
+          <a:prstGeom prst="roundRect">
             <a:avLst/>
           </a:prstGeom>
           <a:solidFill>
-            <a:srgbClr val="FF7F66"/>
+            <a:srgbClr val="FFB464"/>
           </a:solidFill>
           <a:ln>
             <a:noFill/>
@@ -4449,14 +6024,53 @@
       </p:sp>
       <p:sp>
         <p:nvSpPr>
-          <p:cNvPr id="5" name="TextBox 4"/>
+          <p:cNvPr id="7" name="TextBox 6"/>
           <p:cNvSpPr txBox="1"/>
           <p:nvPr/>
         </p:nvSpPr>
         <p:spPr>
           <a:xfrm>
-            <a:off x="914400" y="1828800"/>
-            <a:ext cx="10058400" cy="2286000"/>
+            <a:off x="4953304" y="1024128"/>
+            <a:ext cx="2286000" cy="384048"/>
+          </a:xfrm>
+          <a:prstGeom prst="rect">
+            <a:avLst/>
+          </a:prstGeom>
+          <a:noFill/>
+        </p:spPr>
+        <p:txBody>
+          <a:bodyPr wrap="none">
+            <a:spAutoFit/>
+          </a:bodyPr>
+          <a:lstStyle/>
+          <a:p>
+            <a:pPr algn="ctr">
+              <a:spcAft>
+                <a:spcPts val="1000"/>
+              </a:spcAft>
+            </a:pPr>
+            <a:r>
+              <a:rPr sz="1800" b="1">
+                <a:solidFill>
+                  <a:srgbClr val="502814"/>
+                </a:solidFill>
+                <a:latin typeface="Microsoft YaHei"/>
+              </a:rPr>
+              <a:t>想一想</a:t>
+            </a:r>
+          </a:p>
+        </p:txBody>
+      </p:sp>
+      <p:sp>
+        <p:nvSpPr>
+          <p:cNvPr id="8" name="TextBox 7"/>
+          <p:cNvSpPr txBox="1"/>
+          <p:nvPr/>
+        </p:nvSpPr>
+        <p:spPr>
+          <a:xfrm>
+            <a:off x="1371600" y="1600200"/>
+            <a:ext cx="9418320" cy="822960"/>
           </a:xfrm>
           <a:prstGeom prst="rect">
             <a:avLst/>
@@ -4469,31 +6083,19 @@
           </a:bodyPr>
           <a:lstStyle/>
           <a:p>
-            <a:pPr algn="ctr"/>
-            <a:r>
-              <a:rPr sz="3000" b="1">
+            <a:pPr algn="ctr">
+              <a:spcAft>
+                <a:spcPts val="1000"/>
+              </a:spcAft>
+            </a:pPr>
+            <a:r>
+              <a:rPr sz="3200" b="1">
                 <a:solidFill>
-                  <a:srgbClr val="FF7F66"/>
+                  <a:srgbClr val="DC5028"/>
                 </a:solidFill>
                 <a:latin typeface="Microsoft YaHei"/>
               </a:rPr>
-              <a:t>💭 想一想</a:t>
-            </a:r>
-          </a:p>
-          <a:p>
-            <a:pPr algn="ctr">
-              <a:spcBef>
-                <a:spcPts val="2000"/>
-              </a:spcBef>
-            </a:pPr>
-            <a:r>
-              <a:rPr sz="3400" b="1">
-                <a:solidFill>
-                  <a:srgbClr val="5A606E"/>
-                </a:solidFill>
-                <a:latin typeface="Microsoft YaHei"/>
-              </a:rPr>
-              <a:t>「使神魔皆有人情」
+              <a:t>「使神魔皆有人情，精魅亦通世故」
 课文哪里体现了人情与世故？</a:t>
             </a:r>
           </a:p>
@@ -4501,14 +6103,57 @@
       </p:sp>
       <p:sp>
         <p:nvSpPr>
-          <p:cNvPr id="6" name="TextBox 5"/>
+          <p:cNvPr id="9" name="Rectangle 8"/>
+          <p:cNvSpPr/>
+          <p:nvPr/>
+        </p:nvSpPr>
+        <p:spPr>
+          <a:xfrm>
+            <a:off x="3200400" y="4389120"/>
+            <a:ext cx="5760720" cy="27432"/>
+          </a:xfrm>
+          <a:prstGeom prst="rect">
+            <a:avLst/>
+          </a:prstGeom>
+          <a:solidFill>
+            <a:srgbClr val="FFB464"/>
+          </a:solidFill>
+          <a:ln>
+            <a:noFill/>
+          </a:ln>
+        </p:spPr>
+        <p:style>
+          <a:lnRef idx="1">
+            <a:schemeClr val="accent1"/>
+          </a:lnRef>
+          <a:fillRef idx="3">
+            <a:schemeClr val="accent1"/>
+          </a:fillRef>
+          <a:effectRef idx="2">
+            <a:schemeClr val="accent1"/>
+          </a:effectRef>
+          <a:fontRef idx="minor">
+            <a:schemeClr val="lt1"/>
+          </a:fontRef>
+        </p:style>
+        <p:txBody>
+          <a:bodyPr rtlCol="0" anchor="ctr"/>
+          <a:lstStyle/>
+          <a:p>
+            <a:pPr algn="ctr"/>
+          </a:p>
+        </p:txBody>
+      </p:sp>
+      <p:sp>
+        <p:nvSpPr>
+          <p:cNvPr id="10" name="TextBox 9"/>
           <p:cNvSpPr txBox="1"/>
           <p:nvPr/>
         </p:nvSpPr>
         <p:spPr>
           <a:xfrm>
-            <a:off x="1371600" y="4572000"/>
-            <a:ext cx="9144000" cy="1097280"/>
+            <a:off x="1828800" y="4663440"/>
+            <a:ext cx="8503920" cy="914400"/>
           </a:xfrm>
           <a:prstGeom prst="rect">
             <a:avLst/>
@@ -4521,11 +6166,15 @@
           </a:bodyPr>
           <a:lstStyle/>
           <a:p>
-            <a:pPr algn="ctr"/>
-            <a:r>
-              <a:rPr sz="2400" b="0">
+            <a:pPr algn="ctr">
+              <a:spcAft>
+                <a:spcPts val="1000"/>
+              </a:spcAft>
+            </a:pPr>
+            <a:r>
+              <a:rPr sz="2200" b="0">
                 <a:solidFill>
-                  <a:srgbClr val="FF7F66"/>
+                  <a:srgbClr val="DC5028"/>
                 </a:solidFill>
                 <a:latin typeface="Microsoft YaHei"/>
               </a:rPr>
@@ -4584,17 +6233,17 @@
         </p:nvSpPr>
         <p:spPr>
           <a:xfrm>
-            <a:off x="0" y="0"/>
-            <a:ext cx="12191695" cy="6858000"/>
-          </a:xfrm>
-          <a:prstGeom prst="rect">
-            <a:avLst/>
-          </a:prstGeom>
-          <a:solidFill>
-            <a:srgbClr val="FCFAF7"/>
-          </a:solidFill>
-          <a:ln>
-            <a:noFill/>
+            <a:off x="292608" y="274320"/>
+            <a:ext cx="11594592" cy="6300216"/>
+          </a:xfrm>
+          <a:prstGeom prst="rect">
+            <a:avLst/>
+          </a:prstGeom>
+          <a:noFill/>
+          <a:ln w="31750">
+            <a:solidFill>
+              <a:srgbClr val="C85A32"/>
+            </a:solidFill>
           </a:ln>
         </p:spPr>
         <p:style>
@@ -4619,22 +6268,70 @@
           </a:p>
         </p:txBody>
       </p:sp>
-      <p:sp>
-        <p:nvSpPr>
-          <p:cNvPr id="4" name="Rectangle 3"/>
+      <p:pic>
+        <p:nvPicPr>
+          <p:cNvPr id="4" name="Picture 3" descr="corner_wukong_tl.png"/>
+          <p:cNvPicPr>
+            <a:picLocks noChangeAspect="1"/>
+          </p:cNvPicPr>
+          <p:nvPr/>
+        </p:nvPicPr>
+        <p:blipFill>
+          <a:blip r:embed="rId3"/>
+          <a:stretch>
+            <a:fillRect/>
+          </a:stretch>
+        </p:blipFill>
+        <p:spPr>
+          <a:xfrm>
+            <a:off x="-45720" y="-45720"/>
+            <a:ext cx="2011680" cy="2011680"/>
+          </a:xfrm>
+          <a:prstGeom prst="rect">
+            <a:avLst/>
+          </a:prstGeom>
+        </p:spPr>
+      </p:pic>
+      <p:pic>
+        <p:nvPicPr>
+          <p:cNvPr id="5" name="Picture 4" descr="corner_wukong_tr.png"/>
+          <p:cNvPicPr>
+            <a:picLocks noChangeAspect="1"/>
+          </p:cNvPicPr>
+          <p:nvPr/>
+        </p:nvPicPr>
+        <p:blipFill>
+          <a:blip r:embed="rId4"/>
+          <a:stretch>
+            <a:fillRect/>
+          </a:stretch>
+        </p:blipFill>
+        <p:spPr>
+          <a:xfrm>
+            <a:off x="9875520" y="-45720"/>
+            <a:ext cx="2011680" cy="2011680"/>
+          </a:xfrm>
+          <a:prstGeom prst="rect">
+            <a:avLst/>
+          </a:prstGeom>
+        </p:spPr>
+      </p:pic>
+      <p:sp>
+        <p:nvSpPr>
+          <p:cNvPr id="6" name="Rounded Rectangle 5"/>
           <p:cNvSpPr/>
           <p:nvPr/>
         </p:nvSpPr>
         <p:spPr>
           <a:xfrm>
-            <a:off x="0" y="0"/>
-            <a:ext cx="12191695" cy="91440"/>
-          </a:xfrm>
-          <a:prstGeom prst="rect">
+            <a:off x="4953304" y="502920"/>
+            <a:ext cx="2286000" cy="411480"/>
+          </a:xfrm>
+          <a:prstGeom prst="roundRect">
             <a:avLst/>
           </a:prstGeom>
           <a:solidFill>
-            <a:srgbClr val="B4AAC4"/>
+            <a:srgbClr val="FFB464"/>
           </a:solidFill>
           <a:ln>
             <a:noFill/>
@@ -4664,14 +6361,14 @@
       </p:sp>
       <p:sp>
         <p:nvSpPr>
-          <p:cNvPr id="5" name="TextBox 4"/>
+          <p:cNvPr id="7" name="TextBox 6"/>
           <p:cNvSpPr txBox="1"/>
           <p:nvPr/>
         </p:nvSpPr>
         <p:spPr>
           <a:xfrm>
-            <a:off x="640080" y="228600"/>
-            <a:ext cx="2743200" cy="457200"/>
+            <a:off x="4953304" y="521208"/>
+            <a:ext cx="2286000" cy="384048"/>
           </a:xfrm>
           <a:prstGeom prst="rect">
             <a:avLst/>
@@ -4684,10 +6381,15 @@
           </a:bodyPr>
           <a:lstStyle/>
           <a:p>
-            <a:r>
-              <a:rPr sz="2000" b="1">
+            <a:pPr algn="ctr">
+              <a:spcAft>
+                <a:spcPts val="1000"/>
+              </a:spcAft>
+            </a:pPr>
+            <a:r>
+              <a:rPr sz="1800" b="1">
                 <a:solidFill>
-                  <a:srgbClr val="B4AAC4"/>
+                  <a:srgbClr val="502814"/>
                 </a:solidFill>
                 <a:latin typeface="Microsoft YaHei"/>
               </a:rPr>
@@ -4698,14 +6400,184 @@
       </p:sp>
       <p:sp>
         <p:nvSpPr>
-          <p:cNvPr id="6" name="TextBox 5"/>
+          <p:cNvPr id="8" name="TextBox 7"/>
           <p:cNvSpPr txBox="1"/>
           <p:nvPr/>
         </p:nvSpPr>
         <p:spPr>
           <a:xfrm>
-            <a:off x="640080" y="685800"/>
-            <a:ext cx="10515600" cy="914400"/>
+            <a:off x="1371600" y="960120"/>
+            <a:ext cx="9418320" cy="822960"/>
+          </a:xfrm>
+          <a:prstGeom prst="rect">
+            <a:avLst/>
+          </a:prstGeom>
+          <a:noFill/>
+        </p:spPr>
+        <p:txBody>
+          <a:bodyPr wrap="square">
+            <a:spAutoFit/>
+          </a:bodyPr>
+          <a:lstStyle/>
+          <a:p>
+            <a:pPr algn="ctr">
+              <a:spcAft>
+                <a:spcPts val="1000"/>
+              </a:spcAft>
+            </a:pPr>
+            <a:r>
+              <a:rPr sz="3600" b="1">
+                <a:solidFill>
+                  <a:srgbClr val="DC5028"/>
+                </a:solidFill>
+                <a:latin typeface="Microsoft YaHei"/>
+              </a:rPr>
+              <a:t>学习任务三</a:t>
+            </a:r>
+          </a:p>
+        </p:txBody>
+      </p:sp>
+      <p:sp>
+        <p:nvSpPr>
+          <p:cNvPr id="9" name="Rectangle 8"/>
+          <p:cNvSpPr/>
+          <p:nvPr/>
+        </p:nvSpPr>
+        <p:spPr>
+          <a:xfrm>
+            <a:off x="3200400" y="1600200"/>
+            <a:ext cx="5760720" cy="27432"/>
+          </a:xfrm>
+          <a:prstGeom prst="rect">
+            <a:avLst/>
+          </a:prstGeom>
+          <a:solidFill>
+            <a:srgbClr val="FFB464"/>
+          </a:solidFill>
+          <a:ln>
+            <a:noFill/>
+          </a:ln>
+        </p:spPr>
+        <p:style>
+          <a:lnRef idx="1">
+            <a:schemeClr val="accent1"/>
+          </a:lnRef>
+          <a:fillRef idx="3">
+            <a:schemeClr val="accent1"/>
+          </a:fillRef>
+          <a:effectRef idx="2">
+            <a:schemeClr val="accent1"/>
+          </a:effectRef>
+          <a:fontRef idx="minor">
+            <a:schemeClr val="lt1"/>
+          </a:fontRef>
+        </p:style>
+        <p:txBody>
+          <a:bodyPr rtlCol="0" anchor="ctr"/>
+          <a:lstStyle/>
+          <a:p>
+            <a:pPr algn="ctr"/>
+          </a:p>
+        </p:txBody>
+      </p:sp>
+      <p:sp>
+        <p:nvSpPr>
+          <p:cNvPr id="10" name="Rounded Rectangle 9"/>
+          <p:cNvSpPr/>
+          <p:nvPr/>
+        </p:nvSpPr>
+        <p:spPr>
+          <a:xfrm>
+            <a:off x="1295704" y="1645920"/>
+            <a:ext cx="9601200" cy="2240280"/>
+          </a:xfrm>
+          <a:prstGeom prst="roundRect">
+            <a:avLst/>
+          </a:prstGeom>
+          <a:solidFill>
+            <a:srgbClr val="FFF8F0"/>
+          </a:solidFill>
+          <a:ln w="19050">
+            <a:solidFill>
+              <a:srgbClr val="FFB464"/>
+            </a:solidFill>
+          </a:ln>
+        </p:spPr>
+        <p:style>
+          <a:lnRef idx="1">
+            <a:schemeClr val="accent1"/>
+          </a:lnRef>
+          <a:fillRef idx="3">
+            <a:schemeClr val="accent1"/>
+          </a:fillRef>
+          <a:effectRef idx="2">
+            <a:schemeClr val="accent1"/>
+          </a:effectRef>
+          <a:fontRef idx="minor">
+            <a:schemeClr val="lt1"/>
+          </a:fontRef>
+        </p:style>
+        <p:txBody>
+          <a:bodyPr rtlCol="0" anchor="ctr"/>
+          <a:lstStyle/>
+          <a:p>
+            <a:pPr algn="ctr"/>
+          </a:p>
+        </p:txBody>
+      </p:sp>
+      <p:sp>
+        <p:nvSpPr>
+          <p:cNvPr id="11" name="Oval 10"/>
+          <p:cNvSpPr/>
+          <p:nvPr/>
+        </p:nvSpPr>
+        <p:spPr>
+          <a:xfrm>
+            <a:off x="2255824" y="1828800"/>
+            <a:ext cx="384048" cy="384048"/>
+          </a:xfrm>
+          <a:prstGeom prst="ellipse">
+            <a:avLst/>
+          </a:prstGeom>
+          <a:solidFill>
+            <a:srgbClr val="DC5028"/>
+          </a:solidFill>
+          <a:ln>
+            <a:noFill/>
+          </a:ln>
+        </p:spPr>
+        <p:style>
+          <a:lnRef idx="1">
+            <a:schemeClr val="accent1"/>
+          </a:lnRef>
+          <a:fillRef idx="3">
+            <a:schemeClr val="accent1"/>
+          </a:fillRef>
+          <a:effectRef idx="2">
+            <a:schemeClr val="accent1"/>
+          </a:effectRef>
+          <a:fontRef idx="minor">
+            <a:schemeClr val="lt1"/>
+          </a:fontRef>
+        </p:style>
+        <p:txBody>
+          <a:bodyPr rtlCol="0" anchor="ctr"/>
+          <a:lstStyle/>
+          <a:p>
+            <a:pPr algn="ctr"/>
+          </a:p>
+        </p:txBody>
+      </p:sp>
+      <p:sp>
+        <p:nvSpPr>
+          <p:cNvPr id="12" name="TextBox 11"/>
+          <p:cNvSpPr txBox="1"/>
+          <p:nvPr/>
+        </p:nvSpPr>
+        <p:spPr>
+          <a:xfrm>
+            <a:off x="2255824" y="1847088"/>
+            <a:ext cx="384048" cy="365760"/>
           </a:xfrm>
           <a:prstGeom prst="rect">
             <a:avLst/>
@@ -4718,28 +6590,33 @@
           </a:bodyPr>
           <a:lstStyle/>
           <a:p>
-            <a:r>
-              <a:rPr sz="3600" b="1">
+            <a:pPr algn="ctr">
+              <a:spcAft>
+                <a:spcPts val="1000"/>
+              </a:spcAft>
+            </a:pPr>
+            <a:r>
+              <a:rPr sz="1600" b="1">
                 <a:solidFill>
-                  <a:srgbClr val="5A606E"/>
+                  <a:srgbClr val="FFFFFF"/>
                 </a:solidFill>
                 <a:latin typeface="Microsoft YaHei"/>
               </a:rPr>
-              <a:t>学习任务三 · 提炼策展主题</a:t>
-            </a:r>
-          </a:p>
-        </p:txBody>
-      </p:sp>
-      <p:sp>
-        <p:nvSpPr>
-          <p:cNvPr id="7" name="TextBox 6"/>
+              <a:t>1</a:t>
+            </a:r>
+          </a:p>
+        </p:txBody>
+      </p:sp>
+      <p:sp>
+        <p:nvSpPr>
+          <p:cNvPr id="13" name="TextBox 12"/>
           <p:cNvSpPr txBox="1"/>
           <p:nvPr/>
         </p:nvSpPr>
         <p:spPr>
           <a:xfrm>
-            <a:off x="822960" y="1691640"/>
-            <a:ext cx="10241280" cy="4389120"/>
+            <a:off x="2758744" y="1810512"/>
+            <a:ext cx="7772400" cy="502920"/>
           </a:xfrm>
           <a:prstGeom prst="rect">
             <a:avLst/>
@@ -4747,56 +6624,266 @@
           <a:noFill/>
         </p:spPr>
         <p:txBody>
-          <a:bodyPr wrap="square" anchor="t">
+          <a:bodyPr wrap="none">
             <a:spAutoFit/>
           </a:bodyPr>
           <a:lstStyle/>
           <a:p>
-            <a:pPr>
+            <a:pPr algn="l">
               <a:spcAft>
-                <a:spcPts val="1600"/>
+                <a:spcPts val="1000"/>
               </a:spcAft>
             </a:pPr>
             <a:r>
-              <a:rPr sz="2800" b="0">
+              <a:rPr sz="2400" b="0">
                 <a:solidFill>
-                  <a:srgbClr val="5A606E"/>
+                  <a:srgbClr val="502814"/>
                 </a:solidFill>
                 <a:latin typeface="Microsoft YaHei"/>
               </a:rPr>
-              <a:t>讨论：孙悟空为何逃？天庭为何捉？</a:t>
-            </a:r>
-          </a:p>
-          <a:p>
-            <a:pPr>
+              <a:t>讨论：孙悟空为何逃？天庭为何捉他？</a:t>
+            </a:r>
+          </a:p>
+        </p:txBody>
+      </p:sp>
+      <p:sp>
+        <p:nvSpPr>
+          <p:cNvPr id="14" name="Oval 13"/>
+          <p:cNvSpPr/>
+          <p:nvPr/>
+        </p:nvSpPr>
+        <p:spPr>
+          <a:xfrm>
+            <a:off x="2255824" y="2395728"/>
+            <a:ext cx="384048" cy="384048"/>
+          </a:xfrm>
+          <a:prstGeom prst="ellipse">
+            <a:avLst/>
+          </a:prstGeom>
+          <a:solidFill>
+            <a:srgbClr val="DC5028"/>
+          </a:solidFill>
+          <a:ln>
+            <a:noFill/>
+          </a:ln>
+        </p:spPr>
+        <p:style>
+          <a:lnRef idx="1">
+            <a:schemeClr val="accent1"/>
+          </a:lnRef>
+          <a:fillRef idx="3">
+            <a:schemeClr val="accent1"/>
+          </a:fillRef>
+          <a:effectRef idx="2">
+            <a:schemeClr val="accent1"/>
+          </a:effectRef>
+          <a:fontRef idx="minor">
+            <a:schemeClr val="lt1"/>
+          </a:fontRef>
+        </p:style>
+        <p:txBody>
+          <a:bodyPr rtlCol="0" anchor="ctr"/>
+          <a:lstStyle/>
+          <a:p>
+            <a:pPr algn="ctr"/>
+          </a:p>
+        </p:txBody>
+      </p:sp>
+      <p:sp>
+        <p:nvSpPr>
+          <p:cNvPr id="15" name="TextBox 14"/>
+          <p:cNvSpPr txBox="1"/>
+          <p:nvPr/>
+        </p:nvSpPr>
+        <p:spPr>
+          <a:xfrm>
+            <a:off x="2255824" y="2414016"/>
+            <a:ext cx="384048" cy="365760"/>
+          </a:xfrm>
+          <a:prstGeom prst="rect">
+            <a:avLst/>
+          </a:prstGeom>
+          <a:noFill/>
+        </p:spPr>
+        <p:txBody>
+          <a:bodyPr wrap="none">
+            <a:spAutoFit/>
+          </a:bodyPr>
+          <a:lstStyle/>
+          <a:p>
+            <a:pPr algn="ctr">
               <a:spcAft>
-                <a:spcPts val="1600"/>
+                <a:spcPts val="1000"/>
               </a:spcAft>
             </a:pPr>
             <a:r>
-              <a:rPr sz="2800" b="0">
+              <a:rPr sz="1600" b="1">
                 <a:solidFill>
-                  <a:srgbClr val="5A606E"/>
+                  <a:srgbClr val="FFFFFF"/>
                 </a:solidFill>
                 <a:latin typeface="Microsoft YaHei"/>
               </a:rPr>
-              <a:t>联系生活：自由与规则矛盾吗？</a:t>
-            </a:r>
-          </a:p>
-          <a:p>
-            <a:pPr>
+              <a:t>2</a:t>
+            </a:r>
+          </a:p>
+        </p:txBody>
+      </p:sp>
+      <p:sp>
+        <p:nvSpPr>
+          <p:cNvPr id="16" name="TextBox 15"/>
+          <p:cNvSpPr txBox="1"/>
+          <p:nvPr/>
+        </p:nvSpPr>
+        <p:spPr>
+          <a:xfrm>
+            <a:off x="2758744" y="2377440"/>
+            <a:ext cx="7772400" cy="502920"/>
+          </a:xfrm>
+          <a:prstGeom prst="rect">
+            <a:avLst/>
+          </a:prstGeom>
+          <a:noFill/>
+        </p:spPr>
+        <p:txBody>
+          <a:bodyPr wrap="none">
+            <a:spAutoFit/>
+          </a:bodyPr>
+          <a:lstStyle/>
+          <a:p>
+            <a:pPr algn="l">
               <a:spcAft>
-                <a:spcPts val="1600"/>
+                <a:spcPts val="1000"/>
               </a:spcAft>
             </a:pPr>
             <a:r>
-              <a:rPr sz="2800" b="0">
+              <a:rPr sz="2400" b="0">
                 <a:solidFill>
-                  <a:srgbClr val="5A606E"/>
+                  <a:srgbClr val="502814"/>
                 </a:solidFill>
                 <a:latin typeface="Microsoft YaHei"/>
               </a:rPr>
-              <a:t>主题一：自由可贵，但＿＿＿＿</a:t>
+              <a:t>联系生活：追求自由与遵守规则矛盾吗？</a:t>
+            </a:r>
+          </a:p>
+        </p:txBody>
+      </p:sp>
+      <p:sp>
+        <p:nvSpPr>
+          <p:cNvPr id="17" name="Oval 16"/>
+          <p:cNvSpPr/>
+          <p:nvPr/>
+        </p:nvSpPr>
+        <p:spPr>
+          <a:xfrm>
+            <a:off x="2255824" y="2962656"/>
+            <a:ext cx="384048" cy="384048"/>
+          </a:xfrm>
+          <a:prstGeom prst="ellipse">
+            <a:avLst/>
+          </a:prstGeom>
+          <a:solidFill>
+            <a:srgbClr val="DC5028"/>
+          </a:solidFill>
+          <a:ln>
+            <a:noFill/>
+          </a:ln>
+        </p:spPr>
+        <p:style>
+          <a:lnRef idx="1">
+            <a:schemeClr val="accent1"/>
+          </a:lnRef>
+          <a:fillRef idx="3">
+            <a:schemeClr val="accent1"/>
+          </a:fillRef>
+          <a:effectRef idx="2">
+            <a:schemeClr val="accent1"/>
+          </a:effectRef>
+          <a:fontRef idx="minor">
+            <a:schemeClr val="lt1"/>
+          </a:fontRef>
+        </p:style>
+        <p:txBody>
+          <a:bodyPr rtlCol="0" anchor="ctr"/>
+          <a:lstStyle/>
+          <a:p>
+            <a:pPr algn="ctr"/>
+          </a:p>
+        </p:txBody>
+      </p:sp>
+      <p:sp>
+        <p:nvSpPr>
+          <p:cNvPr id="18" name="TextBox 17"/>
+          <p:cNvSpPr txBox="1"/>
+          <p:nvPr/>
+        </p:nvSpPr>
+        <p:spPr>
+          <a:xfrm>
+            <a:off x="2255824" y="2980944"/>
+            <a:ext cx="384048" cy="365760"/>
+          </a:xfrm>
+          <a:prstGeom prst="rect">
+            <a:avLst/>
+          </a:prstGeom>
+          <a:noFill/>
+        </p:spPr>
+        <p:txBody>
+          <a:bodyPr wrap="none">
+            <a:spAutoFit/>
+          </a:bodyPr>
+          <a:lstStyle/>
+          <a:p>
+            <a:pPr algn="ctr">
+              <a:spcAft>
+                <a:spcPts val="1000"/>
+              </a:spcAft>
+            </a:pPr>
+            <a:r>
+              <a:rPr sz="1600" b="1">
+                <a:solidFill>
+                  <a:srgbClr val="FFFFFF"/>
+                </a:solidFill>
+                <a:latin typeface="Microsoft YaHei"/>
+              </a:rPr>
+              <a:t>3</a:t>
+            </a:r>
+          </a:p>
+        </p:txBody>
+      </p:sp>
+      <p:sp>
+        <p:nvSpPr>
+          <p:cNvPr id="19" name="TextBox 18"/>
+          <p:cNvSpPr txBox="1"/>
+          <p:nvPr/>
+        </p:nvSpPr>
+        <p:spPr>
+          <a:xfrm>
+            <a:off x="2758744" y="2944368"/>
+            <a:ext cx="7772400" cy="502920"/>
+          </a:xfrm>
+          <a:prstGeom prst="rect">
+            <a:avLst/>
+          </a:prstGeom>
+          <a:noFill/>
+        </p:spPr>
+        <p:txBody>
+          <a:bodyPr wrap="none">
+            <a:spAutoFit/>
+          </a:bodyPr>
+          <a:lstStyle/>
+          <a:p>
+            <a:pPr algn="l">
+              <a:spcAft>
+                <a:spcPts val="1000"/>
+              </a:spcAft>
+            </a:pPr>
+            <a:r>
+              <a:rPr sz="2400" b="0">
+                <a:solidFill>
+                  <a:srgbClr val="502814"/>
+                </a:solidFill>
+                <a:latin typeface="Microsoft YaHei"/>
+              </a:rPr>
+              <a:t>策展主题一：自由可贵，但需守规则</a:t>
             </a:r>
           </a:p>
         </p:txBody>
@@ -4851,17 +6938,17 @@
         </p:nvSpPr>
         <p:spPr>
           <a:xfrm>
-            <a:off x="0" y="0"/>
-            <a:ext cx="12191695" cy="6858000"/>
-          </a:xfrm>
-          <a:prstGeom prst="rect">
-            <a:avLst/>
-          </a:prstGeom>
-          <a:solidFill>
-            <a:srgbClr val="FCFAF7"/>
-          </a:solidFill>
-          <a:ln>
-            <a:noFill/>
+            <a:off x="292608" y="274320"/>
+            <a:ext cx="11594592" cy="6300216"/>
+          </a:xfrm>
+          <a:prstGeom prst="rect">
+            <a:avLst/>
+          </a:prstGeom>
+          <a:noFill/>
+          <a:ln w="31750">
+            <a:solidFill>
+              <a:srgbClr val="C85A32"/>
+            </a:solidFill>
           </a:ln>
         </p:spPr>
         <p:style>
@@ -4886,22 +6973,70 @@
           </a:p>
         </p:txBody>
       </p:sp>
-      <p:sp>
-        <p:nvSpPr>
-          <p:cNvPr id="4" name="Rectangle 3"/>
+      <p:pic>
+        <p:nvPicPr>
+          <p:cNvPr id="4" name="Picture 3" descr="corner_wukong_tl.png"/>
+          <p:cNvPicPr>
+            <a:picLocks noChangeAspect="1"/>
+          </p:cNvPicPr>
+          <p:nvPr/>
+        </p:nvPicPr>
+        <p:blipFill>
+          <a:blip r:embed="rId3"/>
+          <a:stretch>
+            <a:fillRect/>
+          </a:stretch>
+        </p:blipFill>
+        <p:spPr>
+          <a:xfrm>
+            <a:off x="-45720" y="-45720"/>
+            <a:ext cx="2011680" cy="2011680"/>
+          </a:xfrm>
+          <a:prstGeom prst="rect">
+            <a:avLst/>
+          </a:prstGeom>
+        </p:spPr>
+      </p:pic>
+      <p:pic>
+        <p:nvPicPr>
+          <p:cNvPr id="5" name="Picture 4" descr="corner_wukong_tr.png"/>
+          <p:cNvPicPr>
+            <a:picLocks noChangeAspect="1"/>
+          </p:cNvPicPr>
+          <p:nvPr/>
+        </p:nvPicPr>
+        <p:blipFill>
+          <a:blip r:embed="rId4"/>
+          <a:stretch>
+            <a:fillRect/>
+          </a:stretch>
+        </p:blipFill>
+        <p:spPr>
+          <a:xfrm>
+            <a:off x="9875520" y="-45720"/>
+            <a:ext cx="2011680" cy="2011680"/>
+          </a:xfrm>
+          <a:prstGeom prst="rect">
+            <a:avLst/>
+          </a:prstGeom>
+        </p:spPr>
+      </p:pic>
+      <p:sp>
+        <p:nvSpPr>
+          <p:cNvPr id="6" name="Rounded Rectangle 5"/>
           <p:cNvSpPr/>
           <p:nvPr/>
         </p:nvSpPr>
         <p:spPr>
           <a:xfrm>
-            <a:off x="0" y="0"/>
-            <a:ext cx="12191695" cy="91440"/>
-          </a:xfrm>
-          <a:prstGeom prst="rect">
+            <a:off x="4953304" y="502920"/>
+            <a:ext cx="2286000" cy="411480"/>
+          </a:xfrm>
+          <a:prstGeom prst="roundRect">
             <a:avLst/>
           </a:prstGeom>
           <a:solidFill>
-            <a:srgbClr val="FF7F66"/>
+            <a:srgbClr val="FFB464"/>
           </a:solidFill>
           <a:ln>
             <a:noFill/>
@@ -4931,14 +7066,14 @@
       </p:sp>
       <p:sp>
         <p:nvSpPr>
-          <p:cNvPr id="5" name="TextBox 4"/>
+          <p:cNvPr id="7" name="TextBox 6"/>
           <p:cNvSpPr txBox="1"/>
           <p:nvPr/>
         </p:nvSpPr>
         <p:spPr>
           <a:xfrm>
-            <a:off x="640080" y="228600"/>
-            <a:ext cx="2743200" cy="457200"/>
+            <a:off x="4953304" y="521208"/>
+            <a:ext cx="2286000" cy="384048"/>
           </a:xfrm>
           <a:prstGeom prst="rect">
             <a:avLst/>
@@ -4951,10 +7086,15 @@
           </a:bodyPr>
           <a:lstStyle/>
           <a:p>
-            <a:r>
-              <a:rPr sz="2000" b="1">
+            <a:pPr algn="ctr">
+              <a:spcAft>
+                <a:spcPts val="1000"/>
+              </a:spcAft>
+            </a:pPr>
+            <a:r>
+              <a:rPr sz="1800" b="1">
                 <a:solidFill>
-                  <a:srgbClr val="FF7F66"/>
+                  <a:srgbClr val="502814"/>
                 </a:solidFill>
                 <a:latin typeface="Microsoft YaHei"/>
               </a:rPr>
@@ -4965,14 +7105,14 @@
       </p:sp>
       <p:sp>
         <p:nvSpPr>
-          <p:cNvPr id="6" name="TextBox 5"/>
+          <p:cNvPr id="8" name="TextBox 7"/>
           <p:cNvSpPr txBox="1"/>
           <p:nvPr/>
         </p:nvSpPr>
         <p:spPr>
           <a:xfrm>
-            <a:off x="640080" y="685800"/>
-            <a:ext cx="10515600" cy="914400"/>
+            <a:off x="1371600" y="960120"/>
+            <a:ext cx="9418320" cy="822960"/>
           </a:xfrm>
           <a:prstGeom prst="rect">
             <a:avLst/>
@@ -4980,15 +7120,20 @@
           <a:noFill/>
         </p:spPr>
         <p:txBody>
-          <a:bodyPr wrap="none">
+          <a:bodyPr wrap="square">
             <a:spAutoFit/>
           </a:bodyPr>
           <a:lstStyle/>
           <a:p>
+            <a:pPr algn="ctr">
+              <a:spcAft>
+                <a:spcPts val="1000"/>
+              </a:spcAft>
+            </a:pPr>
             <a:r>
               <a:rPr sz="3600" b="1">
                 <a:solidFill>
-                  <a:srgbClr val="5A606E"/>
+                  <a:srgbClr val="DC5028"/>
                 </a:solidFill>
                 <a:latin typeface="Microsoft YaHei"/>
               </a:rPr>
@@ -4999,14 +7144,145 @@
       </p:sp>
       <p:sp>
         <p:nvSpPr>
-          <p:cNvPr id="7" name="TextBox 6"/>
+          <p:cNvPr id="9" name="Rectangle 8"/>
+          <p:cNvSpPr/>
+          <p:nvPr/>
+        </p:nvSpPr>
+        <p:spPr>
+          <a:xfrm>
+            <a:off x="3200400" y="1600200"/>
+            <a:ext cx="5760720" cy="27432"/>
+          </a:xfrm>
+          <a:prstGeom prst="rect">
+            <a:avLst/>
+          </a:prstGeom>
+          <a:solidFill>
+            <a:srgbClr val="FFB464"/>
+          </a:solidFill>
+          <a:ln>
+            <a:noFill/>
+          </a:ln>
+        </p:spPr>
+        <p:style>
+          <a:lnRef idx="1">
+            <a:schemeClr val="accent1"/>
+          </a:lnRef>
+          <a:fillRef idx="3">
+            <a:schemeClr val="accent1"/>
+          </a:fillRef>
+          <a:effectRef idx="2">
+            <a:schemeClr val="accent1"/>
+          </a:effectRef>
+          <a:fontRef idx="minor">
+            <a:schemeClr val="lt1"/>
+          </a:fontRef>
+        </p:style>
+        <p:txBody>
+          <a:bodyPr rtlCol="0" anchor="ctr"/>
+          <a:lstStyle/>
+          <a:p>
+            <a:pPr algn="ctr"/>
+          </a:p>
+        </p:txBody>
+      </p:sp>
+      <p:sp>
+        <p:nvSpPr>
+          <p:cNvPr id="10" name="Rounded Rectangle 9"/>
+          <p:cNvSpPr/>
+          <p:nvPr/>
+        </p:nvSpPr>
+        <p:spPr>
+          <a:xfrm>
+            <a:off x="1295704" y="1645920"/>
+            <a:ext cx="9601200" cy="2240280"/>
+          </a:xfrm>
+          <a:prstGeom prst="roundRect">
+            <a:avLst/>
+          </a:prstGeom>
+          <a:solidFill>
+            <a:srgbClr val="FFF8F0"/>
+          </a:solidFill>
+          <a:ln w="19050">
+            <a:solidFill>
+              <a:srgbClr val="FFB464"/>
+            </a:solidFill>
+          </a:ln>
+        </p:spPr>
+        <p:style>
+          <a:lnRef idx="1">
+            <a:schemeClr val="accent1"/>
+          </a:lnRef>
+          <a:fillRef idx="3">
+            <a:schemeClr val="accent1"/>
+          </a:fillRef>
+          <a:effectRef idx="2">
+            <a:schemeClr val="accent1"/>
+          </a:effectRef>
+          <a:fontRef idx="minor">
+            <a:schemeClr val="lt1"/>
+          </a:fontRef>
+        </p:style>
+        <p:txBody>
+          <a:bodyPr rtlCol="0" anchor="ctr"/>
+          <a:lstStyle/>
+          <a:p>
+            <a:pPr algn="ctr"/>
+          </a:p>
+        </p:txBody>
+      </p:sp>
+      <p:sp>
+        <p:nvSpPr>
+          <p:cNvPr id="11" name="Oval 10"/>
+          <p:cNvSpPr/>
+          <p:nvPr/>
+        </p:nvSpPr>
+        <p:spPr>
+          <a:xfrm>
+            <a:off x="2255824" y="1828800"/>
+            <a:ext cx="384048" cy="384048"/>
+          </a:xfrm>
+          <a:prstGeom prst="ellipse">
+            <a:avLst/>
+          </a:prstGeom>
+          <a:solidFill>
+            <a:srgbClr val="DC5028"/>
+          </a:solidFill>
+          <a:ln>
+            <a:noFill/>
+          </a:ln>
+        </p:spPr>
+        <p:style>
+          <a:lnRef idx="1">
+            <a:schemeClr val="accent1"/>
+          </a:lnRef>
+          <a:fillRef idx="3">
+            <a:schemeClr val="accent1"/>
+          </a:fillRef>
+          <a:effectRef idx="2">
+            <a:schemeClr val="accent1"/>
+          </a:effectRef>
+          <a:fontRef idx="minor">
+            <a:schemeClr val="lt1"/>
+          </a:fontRef>
+        </p:style>
+        <p:txBody>
+          <a:bodyPr rtlCol="0" anchor="ctr"/>
+          <a:lstStyle/>
+          <a:p>
+            <a:pPr algn="ctr"/>
+          </a:p>
+        </p:txBody>
+      </p:sp>
+      <p:sp>
+        <p:nvSpPr>
+          <p:cNvPr id="12" name="TextBox 11"/>
           <p:cNvSpPr txBox="1"/>
           <p:nvPr/>
         </p:nvSpPr>
         <p:spPr>
           <a:xfrm>
-            <a:off x="822960" y="1691640"/>
-            <a:ext cx="10241280" cy="4389120"/>
+            <a:off x="2255824" y="1847088"/>
+            <a:ext cx="384048" cy="365760"/>
           </a:xfrm>
           <a:prstGeom prst="rect">
             <a:avLst/>
@@ -5014,52 +7290,301 @@
           <a:noFill/>
         </p:spPr>
         <p:txBody>
-          <a:bodyPr wrap="square" anchor="t">
+          <a:bodyPr wrap="none">
             <a:spAutoFit/>
           </a:bodyPr>
           <a:lstStyle/>
           <a:p>
-            <a:pPr>
+            <a:pPr algn="ctr">
               <a:spcAft>
-                <a:spcPts val="1600"/>
+                <a:spcPts val="1000"/>
               </a:spcAft>
             </a:pPr>
             <a:r>
-              <a:rPr sz="2800" b="0">
+              <a:rPr sz="1600" b="1">
                 <a:solidFill>
-                  <a:srgbClr val="5A606E"/>
+                  <a:srgbClr val="FFFFFF"/>
+                </a:solidFill>
+                <a:latin typeface="Microsoft YaHei"/>
+              </a:rPr>
+              <a:t>1</a:t>
+            </a:r>
+          </a:p>
+        </p:txBody>
+      </p:sp>
+      <p:sp>
+        <p:nvSpPr>
+          <p:cNvPr id="13" name="TextBox 12"/>
+          <p:cNvSpPr txBox="1"/>
+          <p:nvPr/>
+        </p:nvSpPr>
+        <p:spPr>
+          <a:xfrm>
+            <a:off x="2758744" y="1810512"/>
+            <a:ext cx="7772400" cy="502920"/>
+          </a:xfrm>
+          <a:prstGeom prst="rect">
+            <a:avLst/>
+          </a:prstGeom>
+          <a:noFill/>
+        </p:spPr>
+        <p:txBody>
+          <a:bodyPr wrap="none">
+            <a:spAutoFit/>
+          </a:bodyPr>
+          <a:lstStyle/>
+          <a:p>
+            <a:pPr algn="l">
+              <a:spcAft>
+                <a:spcPts val="1000"/>
+              </a:spcAft>
+            </a:pPr>
+            <a:r>
+              <a:rPr sz="2400" b="0">
+                <a:solidFill>
+                  <a:srgbClr val="502814"/>
                 </a:solidFill>
                 <a:latin typeface="Microsoft YaHei"/>
               </a:rPr>
               <a:t>想象精彩，来自变化中的因果回应</a:t>
             </a:r>
           </a:p>
-          <a:p>
-            <a:pPr>
+        </p:txBody>
+      </p:sp>
+      <p:sp>
+        <p:nvSpPr>
+          <p:cNvPr id="14" name="Oval 13"/>
+          <p:cNvSpPr/>
+          <p:nvPr/>
+        </p:nvSpPr>
+        <p:spPr>
+          <a:xfrm>
+            <a:off x="2255824" y="2395728"/>
+            <a:ext cx="384048" cy="384048"/>
+          </a:xfrm>
+          <a:prstGeom prst="ellipse">
+            <a:avLst/>
+          </a:prstGeom>
+          <a:solidFill>
+            <a:srgbClr val="DC5028"/>
+          </a:solidFill>
+          <a:ln>
+            <a:noFill/>
+          </a:ln>
+        </p:spPr>
+        <p:style>
+          <a:lnRef idx="1">
+            <a:schemeClr val="accent1"/>
+          </a:lnRef>
+          <a:fillRef idx="3">
+            <a:schemeClr val="accent1"/>
+          </a:fillRef>
+          <a:effectRef idx="2">
+            <a:schemeClr val="accent1"/>
+          </a:effectRef>
+          <a:fontRef idx="minor">
+            <a:schemeClr val="lt1"/>
+          </a:fontRef>
+        </p:style>
+        <p:txBody>
+          <a:bodyPr rtlCol="0" anchor="ctr"/>
+          <a:lstStyle/>
+          <a:p>
+            <a:pPr algn="ctr"/>
+          </a:p>
+        </p:txBody>
+      </p:sp>
+      <p:sp>
+        <p:nvSpPr>
+          <p:cNvPr id="15" name="TextBox 14"/>
+          <p:cNvSpPr txBox="1"/>
+          <p:nvPr/>
+        </p:nvSpPr>
+        <p:spPr>
+          <a:xfrm>
+            <a:off x="2255824" y="2414016"/>
+            <a:ext cx="384048" cy="365760"/>
+          </a:xfrm>
+          <a:prstGeom prst="rect">
+            <a:avLst/>
+          </a:prstGeom>
+          <a:noFill/>
+        </p:spPr>
+        <p:txBody>
+          <a:bodyPr wrap="none">
+            <a:spAutoFit/>
+          </a:bodyPr>
+          <a:lstStyle/>
+          <a:p>
+            <a:pPr algn="ctr">
               <a:spcAft>
-                <a:spcPts val="1600"/>
+                <a:spcPts val="1000"/>
               </a:spcAft>
             </a:pPr>
             <a:r>
-              <a:rPr sz="2800" b="0">
+              <a:rPr sz="1600" b="1">
                 <a:solidFill>
-                  <a:srgbClr val="5A606E"/>
+                  <a:srgbClr val="FFFFFF"/>
                 </a:solidFill>
                 <a:latin typeface="Microsoft YaHei"/>
               </a:rPr>
-              <a:t>神魔有法力，也有人情味</a:t>
-            </a:r>
-          </a:p>
-          <a:p>
-            <a:pPr>
+              <a:t>2</a:t>
+            </a:r>
+          </a:p>
+        </p:txBody>
+      </p:sp>
+      <p:sp>
+        <p:nvSpPr>
+          <p:cNvPr id="16" name="TextBox 15"/>
+          <p:cNvSpPr txBox="1"/>
+          <p:nvPr/>
+        </p:nvSpPr>
+        <p:spPr>
+          <a:xfrm>
+            <a:off x="2758744" y="2377440"/>
+            <a:ext cx="7772400" cy="502920"/>
+          </a:xfrm>
+          <a:prstGeom prst="rect">
+            <a:avLst/>
+          </a:prstGeom>
+          <a:noFill/>
+        </p:spPr>
+        <p:txBody>
+          <a:bodyPr wrap="none">
+            <a:spAutoFit/>
+          </a:bodyPr>
+          <a:lstStyle/>
+          <a:p>
+            <a:pPr algn="l">
               <a:spcAft>
-                <a:spcPts val="1600"/>
+                <a:spcPts val="1000"/>
               </a:spcAft>
             </a:pPr>
             <a:r>
-              <a:rPr sz="2800" b="0">
+              <a:rPr sz="2400" b="0">
                 <a:solidFill>
-                  <a:srgbClr val="5A606E"/>
+                  <a:srgbClr val="502814"/>
+                </a:solidFill>
+                <a:latin typeface="Microsoft YaHei"/>
+              </a:rPr>
+              <a:t>神魔有法力，也有机敏、急切、好胜等人情味</a:t>
+            </a:r>
+          </a:p>
+        </p:txBody>
+      </p:sp>
+      <p:sp>
+        <p:nvSpPr>
+          <p:cNvPr id="17" name="Oval 16"/>
+          <p:cNvSpPr/>
+          <p:nvPr/>
+        </p:nvSpPr>
+        <p:spPr>
+          <a:xfrm>
+            <a:off x="2255824" y="2962656"/>
+            <a:ext cx="384048" cy="384048"/>
+          </a:xfrm>
+          <a:prstGeom prst="ellipse">
+            <a:avLst/>
+          </a:prstGeom>
+          <a:solidFill>
+            <a:srgbClr val="DC5028"/>
+          </a:solidFill>
+          <a:ln>
+            <a:noFill/>
+          </a:ln>
+        </p:spPr>
+        <p:style>
+          <a:lnRef idx="1">
+            <a:schemeClr val="accent1"/>
+          </a:lnRef>
+          <a:fillRef idx="3">
+            <a:schemeClr val="accent1"/>
+          </a:fillRef>
+          <a:effectRef idx="2">
+            <a:schemeClr val="accent1"/>
+          </a:effectRef>
+          <a:fontRef idx="minor">
+            <a:schemeClr val="lt1"/>
+          </a:fontRef>
+        </p:style>
+        <p:txBody>
+          <a:bodyPr rtlCol="0" anchor="ctr"/>
+          <a:lstStyle/>
+          <a:p>
+            <a:pPr algn="ctr"/>
+          </a:p>
+        </p:txBody>
+      </p:sp>
+      <p:sp>
+        <p:nvSpPr>
+          <p:cNvPr id="18" name="TextBox 17"/>
+          <p:cNvSpPr txBox="1"/>
+          <p:nvPr/>
+        </p:nvSpPr>
+        <p:spPr>
+          <a:xfrm>
+            <a:off x="2255824" y="2980944"/>
+            <a:ext cx="384048" cy="365760"/>
+          </a:xfrm>
+          <a:prstGeom prst="rect">
+            <a:avLst/>
+          </a:prstGeom>
+          <a:noFill/>
+        </p:spPr>
+        <p:txBody>
+          <a:bodyPr wrap="none">
+            <a:spAutoFit/>
+          </a:bodyPr>
+          <a:lstStyle/>
+          <a:p>
+            <a:pPr algn="ctr">
+              <a:spcAft>
+                <a:spcPts val="1000"/>
+              </a:spcAft>
+            </a:pPr>
+            <a:r>
+              <a:rPr sz="1600" b="1">
+                <a:solidFill>
+                  <a:srgbClr val="FFFFFF"/>
+                </a:solidFill>
+                <a:latin typeface="Microsoft YaHei"/>
+              </a:rPr>
+              <a:t>3</a:t>
+            </a:r>
+          </a:p>
+        </p:txBody>
+      </p:sp>
+      <p:sp>
+        <p:nvSpPr>
+          <p:cNvPr id="19" name="TextBox 18"/>
+          <p:cNvSpPr txBox="1"/>
+          <p:nvPr/>
+        </p:nvSpPr>
+        <p:spPr>
+          <a:xfrm>
+            <a:off x="2758744" y="2944368"/>
+            <a:ext cx="7772400" cy="502920"/>
+          </a:xfrm>
+          <a:prstGeom prst="rect">
+            <a:avLst/>
+          </a:prstGeom>
+          <a:noFill/>
+        </p:spPr>
+        <p:txBody>
+          <a:bodyPr wrap="none">
+            <a:spAutoFit/>
+          </a:bodyPr>
+          <a:lstStyle/>
+          <a:p>
+            <a:pPr algn="l">
+              <a:spcAft>
+                <a:spcPts val="1000"/>
+              </a:spcAft>
+            </a:pPr>
+            <a:r>
+              <a:rPr sz="2400" b="0">
+                <a:solidFill>
+                  <a:srgbClr val="502814"/>
                 </a:solidFill>
                 <a:latin typeface="Microsoft YaHei"/>
               </a:rPr>
@@ -5118,17 +7643,17 @@
         </p:nvSpPr>
         <p:spPr>
           <a:xfrm>
-            <a:off x="0" y="0"/>
-            <a:ext cx="12191695" cy="6858000"/>
-          </a:xfrm>
-          <a:prstGeom prst="rect">
-            <a:avLst/>
-          </a:prstGeom>
-          <a:solidFill>
-            <a:srgbClr val="FCFAF7"/>
-          </a:solidFill>
-          <a:ln>
-            <a:noFill/>
+            <a:off x="292608" y="274320"/>
+            <a:ext cx="11594592" cy="6300216"/>
+          </a:xfrm>
+          <a:prstGeom prst="rect">
+            <a:avLst/>
+          </a:prstGeom>
+          <a:noFill/>
+          <a:ln w="31750">
+            <a:solidFill>
+              <a:srgbClr val="C85A32"/>
+            </a:solidFill>
           </a:ln>
         </p:spPr>
         <p:style>
@@ -5153,22 +7678,70 @@
           </a:p>
         </p:txBody>
       </p:sp>
-      <p:sp>
-        <p:nvSpPr>
-          <p:cNvPr id="4" name="Rectangle 3"/>
+      <p:pic>
+        <p:nvPicPr>
+          <p:cNvPr id="4" name="Picture 3" descr="corner_wukong_tl.png"/>
+          <p:cNvPicPr>
+            <a:picLocks noChangeAspect="1"/>
+          </p:cNvPicPr>
+          <p:nvPr/>
+        </p:nvPicPr>
+        <p:blipFill>
+          <a:blip r:embed="rId3"/>
+          <a:stretch>
+            <a:fillRect/>
+          </a:stretch>
+        </p:blipFill>
+        <p:spPr>
+          <a:xfrm>
+            <a:off x="-45720" y="-45720"/>
+            <a:ext cx="2011680" cy="2011680"/>
+          </a:xfrm>
+          <a:prstGeom prst="rect">
+            <a:avLst/>
+          </a:prstGeom>
+        </p:spPr>
+      </p:pic>
+      <p:pic>
+        <p:nvPicPr>
+          <p:cNvPr id="5" name="Picture 4" descr="corner_wukong_tr.png"/>
+          <p:cNvPicPr>
+            <a:picLocks noChangeAspect="1"/>
+          </p:cNvPicPr>
+          <p:nvPr/>
+        </p:nvPicPr>
+        <p:blipFill>
+          <a:blip r:embed="rId4"/>
+          <a:stretch>
+            <a:fillRect/>
+          </a:stretch>
+        </p:blipFill>
+        <p:spPr>
+          <a:xfrm>
+            <a:off x="9875520" y="-45720"/>
+            <a:ext cx="2011680" cy="2011680"/>
+          </a:xfrm>
+          <a:prstGeom prst="rect">
+            <a:avLst/>
+          </a:prstGeom>
+        </p:spPr>
+      </p:pic>
+      <p:sp>
+        <p:nvSpPr>
+          <p:cNvPr id="6" name="Rounded Rectangle 5"/>
           <p:cNvSpPr/>
           <p:nvPr/>
         </p:nvSpPr>
         <p:spPr>
           <a:xfrm>
-            <a:off x="0" y="0"/>
-            <a:ext cx="12191695" cy="91440"/>
-          </a:xfrm>
-          <a:prstGeom prst="rect">
+            <a:off x="4953304" y="502920"/>
+            <a:ext cx="2286000" cy="411480"/>
+          </a:xfrm>
+          <a:prstGeom prst="roundRect">
             <a:avLst/>
           </a:prstGeom>
           <a:solidFill>
-            <a:srgbClr val="FFB799"/>
+            <a:srgbClr val="FFB464"/>
           </a:solidFill>
           <a:ln>
             <a:noFill/>
@@ -5198,14 +7771,14 @@
       </p:sp>
       <p:sp>
         <p:nvSpPr>
-          <p:cNvPr id="5" name="TextBox 4"/>
+          <p:cNvPr id="7" name="TextBox 6"/>
           <p:cNvSpPr txBox="1"/>
           <p:nvPr/>
         </p:nvSpPr>
         <p:spPr>
           <a:xfrm>
-            <a:off x="640080" y="228600"/>
-            <a:ext cx="2743200" cy="457200"/>
+            <a:off x="4953304" y="521208"/>
+            <a:ext cx="2286000" cy="384048"/>
           </a:xfrm>
           <a:prstGeom prst="rect">
             <a:avLst/>
@@ -5218,10 +7791,15 @@
           </a:bodyPr>
           <a:lstStyle/>
           <a:p>
-            <a:r>
-              <a:rPr sz="2000" b="1">
+            <a:pPr algn="ctr">
+              <a:spcAft>
+                <a:spcPts val="1000"/>
+              </a:spcAft>
+            </a:pPr>
+            <a:r>
+              <a:rPr sz="1800" b="1">
                 <a:solidFill>
-                  <a:srgbClr val="FFB799"/>
+                  <a:srgbClr val="502814"/>
                 </a:solidFill>
                 <a:latin typeface="Microsoft YaHei"/>
               </a:rPr>
@@ -5232,14 +7810,184 @@
       </p:sp>
       <p:sp>
         <p:nvSpPr>
-          <p:cNvPr id="6" name="TextBox 5"/>
+          <p:cNvPr id="8" name="TextBox 7"/>
           <p:cNvSpPr txBox="1"/>
           <p:nvPr/>
         </p:nvSpPr>
         <p:spPr>
           <a:xfrm>
-            <a:off x="640080" y="685800"/>
-            <a:ext cx="10515600" cy="914400"/>
+            <a:off x="1371600" y="960120"/>
+            <a:ext cx="9418320" cy="822960"/>
+          </a:xfrm>
+          <a:prstGeom prst="rect">
+            <a:avLst/>
+          </a:prstGeom>
+          <a:noFill/>
+        </p:spPr>
+        <p:txBody>
+          <a:bodyPr wrap="square">
+            <a:spAutoFit/>
+          </a:bodyPr>
+          <a:lstStyle/>
+          <a:p>
+            <a:pPr algn="ctr">
+              <a:spcAft>
+                <a:spcPts val="1000"/>
+              </a:spcAft>
+            </a:pPr>
+            <a:r>
+              <a:rPr sz="3600" b="1">
+                <a:solidFill>
+                  <a:srgbClr val="DC5028"/>
+                </a:solidFill>
+                <a:latin typeface="Microsoft YaHei"/>
+              </a:rPr>
+              <a:t>课后作业</a:t>
+            </a:r>
+          </a:p>
+        </p:txBody>
+      </p:sp>
+      <p:sp>
+        <p:nvSpPr>
+          <p:cNvPr id="9" name="Rectangle 8"/>
+          <p:cNvSpPr/>
+          <p:nvPr/>
+        </p:nvSpPr>
+        <p:spPr>
+          <a:xfrm>
+            <a:off x="3200400" y="1600200"/>
+            <a:ext cx="5760720" cy="27432"/>
+          </a:xfrm>
+          <a:prstGeom prst="rect">
+            <a:avLst/>
+          </a:prstGeom>
+          <a:solidFill>
+            <a:srgbClr val="FFB464"/>
+          </a:solidFill>
+          <a:ln>
+            <a:noFill/>
+          </a:ln>
+        </p:spPr>
+        <p:style>
+          <a:lnRef idx="1">
+            <a:schemeClr val="accent1"/>
+          </a:lnRef>
+          <a:fillRef idx="3">
+            <a:schemeClr val="accent1"/>
+          </a:fillRef>
+          <a:effectRef idx="2">
+            <a:schemeClr val="accent1"/>
+          </a:effectRef>
+          <a:fontRef idx="minor">
+            <a:schemeClr val="lt1"/>
+          </a:fontRef>
+        </p:style>
+        <p:txBody>
+          <a:bodyPr rtlCol="0" anchor="ctr"/>
+          <a:lstStyle/>
+          <a:p>
+            <a:pPr algn="ctr"/>
+          </a:p>
+        </p:txBody>
+      </p:sp>
+      <p:sp>
+        <p:nvSpPr>
+          <p:cNvPr id="10" name="Rounded Rectangle 9"/>
+          <p:cNvSpPr/>
+          <p:nvPr/>
+        </p:nvSpPr>
+        <p:spPr>
+          <a:xfrm>
+            <a:off x="1295704" y="1645920"/>
+            <a:ext cx="9601200" cy="1645920"/>
+          </a:xfrm>
+          <a:prstGeom prst="roundRect">
+            <a:avLst/>
+          </a:prstGeom>
+          <a:solidFill>
+            <a:srgbClr val="FFF8F0"/>
+          </a:solidFill>
+          <a:ln w="19050">
+            <a:solidFill>
+              <a:srgbClr val="FFB464"/>
+            </a:solidFill>
+          </a:ln>
+        </p:spPr>
+        <p:style>
+          <a:lnRef idx="1">
+            <a:schemeClr val="accent1"/>
+          </a:lnRef>
+          <a:fillRef idx="3">
+            <a:schemeClr val="accent1"/>
+          </a:fillRef>
+          <a:effectRef idx="2">
+            <a:schemeClr val="accent1"/>
+          </a:effectRef>
+          <a:fontRef idx="minor">
+            <a:schemeClr val="lt1"/>
+          </a:fontRef>
+        </p:style>
+        <p:txBody>
+          <a:bodyPr rtlCol="0" anchor="ctr"/>
+          <a:lstStyle/>
+          <a:p>
+            <a:pPr algn="ctr"/>
+          </a:p>
+        </p:txBody>
+      </p:sp>
+      <p:sp>
+        <p:nvSpPr>
+          <p:cNvPr id="11" name="Oval 10"/>
+          <p:cNvSpPr/>
+          <p:nvPr/>
+        </p:nvSpPr>
+        <p:spPr>
+          <a:xfrm>
+            <a:off x="2255824" y="1828800"/>
+            <a:ext cx="384048" cy="384048"/>
+          </a:xfrm>
+          <a:prstGeom prst="ellipse">
+            <a:avLst/>
+          </a:prstGeom>
+          <a:solidFill>
+            <a:srgbClr val="DC5028"/>
+          </a:solidFill>
+          <a:ln>
+            <a:noFill/>
+          </a:ln>
+        </p:spPr>
+        <p:style>
+          <a:lnRef idx="1">
+            <a:schemeClr val="accent1"/>
+          </a:lnRef>
+          <a:fillRef idx="3">
+            <a:schemeClr val="accent1"/>
+          </a:fillRef>
+          <a:effectRef idx="2">
+            <a:schemeClr val="accent1"/>
+          </a:effectRef>
+          <a:fontRef idx="minor">
+            <a:schemeClr val="lt1"/>
+          </a:fontRef>
+        </p:style>
+        <p:txBody>
+          <a:bodyPr rtlCol="0" anchor="ctr"/>
+          <a:lstStyle/>
+          <a:p>
+            <a:pPr algn="ctr"/>
+          </a:p>
+        </p:txBody>
+      </p:sp>
+      <p:sp>
+        <p:nvSpPr>
+          <p:cNvPr id="12" name="TextBox 11"/>
+          <p:cNvSpPr txBox="1"/>
+          <p:nvPr/>
+        </p:nvSpPr>
+        <p:spPr>
+          <a:xfrm>
+            <a:off x="2255824" y="1847088"/>
+            <a:ext cx="384048" cy="365760"/>
           </a:xfrm>
           <a:prstGeom prst="rect">
             <a:avLst/>
@@ -5252,28 +8000,33 @@
           </a:bodyPr>
           <a:lstStyle/>
           <a:p>
-            <a:r>
-              <a:rPr sz="3600" b="1">
+            <a:pPr algn="ctr">
+              <a:spcAft>
+                <a:spcPts val="1000"/>
+              </a:spcAft>
+            </a:pPr>
+            <a:r>
+              <a:rPr sz="1600" b="1">
                 <a:solidFill>
-                  <a:srgbClr val="5A606E"/>
+                  <a:srgbClr val="FFFFFF"/>
                 </a:solidFill>
                 <a:latin typeface="Microsoft YaHei"/>
               </a:rPr>
-              <a:t>作业</a:t>
-            </a:r>
-          </a:p>
-        </p:txBody>
-      </p:sp>
-      <p:sp>
-        <p:nvSpPr>
-          <p:cNvPr id="7" name="TextBox 6"/>
+              <a:t>1</a:t>
+            </a:r>
+          </a:p>
+        </p:txBody>
+      </p:sp>
+      <p:sp>
+        <p:nvSpPr>
+          <p:cNvPr id="13" name="TextBox 12"/>
           <p:cNvSpPr txBox="1"/>
           <p:nvPr/>
         </p:nvSpPr>
         <p:spPr>
           <a:xfrm>
-            <a:off x="822960" y="1691640"/>
-            <a:ext cx="10241280" cy="4389120"/>
+            <a:off x="2758744" y="1810512"/>
+            <a:ext cx="7772400" cy="502920"/>
           </a:xfrm>
           <a:prstGeom prst="rect">
             <a:avLst/>
@@ -5281,58 +8034,145 @@
           <a:noFill/>
         </p:spPr>
         <p:txBody>
-          <a:bodyPr wrap="square" anchor="t">
+          <a:bodyPr wrap="none">
             <a:spAutoFit/>
           </a:bodyPr>
           <a:lstStyle/>
           <a:p>
-            <a:pPr>
+            <a:pPr algn="l">
               <a:spcAft>
-                <a:spcPts val="1600"/>
+                <a:spcPts val="1000"/>
               </a:spcAft>
             </a:pPr>
             <a:r>
-              <a:rPr sz="2600" b="1">
+              <a:rPr sz="2400" b="0">
                 <a:solidFill>
-                  <a:srgbClr val="FFB799"/>
+                  <a:srgbClr val="502814"/>
                 </a:solidFill>
                 <a:latin typeface="Microsoft YaHei"/>
               </a:rPr>
-              <a:t>必做  </a:t>
-            </a:r>
-            <a:r>
-              <a:rPr sz="2600" b="0">
+              <a:t>必做：写80字「赛事快讯」（至少三次变化）</a:t>
+            </a:r>
+          </a:p>
+        </p:txBody>
+      </p:sp>
+      <p:sp>
+        <p:nvSpPr>
+          <p:cNvPr id="14" name="Oval 13"/>
+          <p:cNvSpPr/>
+          <p:nvPr/>
+        </p:nvSpPr>
+        <p:spPr>
+          <a:xfrm>
+            <a:off x="2255824" y="2395728"/>
+            <a:ext cx="384048" cy="384048"/>
+          </a:xfrm>
+          <a:prstGeom prst="ellipse">
+            <a:avLst/>
+          </a:prstGeom>
+          <a:solidFill>
+            <a:srgbClr val="DC5028"/>
+          </a:solidFill>
+          <a:ln>
+            <a:noFill/>
+          </a:ln>
+        </p:spPr>
+        <p:style>
+          <a:lnRef idx="1">
+            <a:schemeClr val="accent1"/>
+          </a:lnRef>
+          <a:fillRef idx="3">
+            <a:schemeClr val="accent1"/>
+          </a:fillRef>
+          <a:effectRef idx="2">
+            <a:schemeClr val="accent1"/>
+          </a:effectRef>
+          <a:fontRef idx="minor">
+            <a:schemeClr val="lt1"/>
+          </a:fontRef>
+        </p:style>
+        <p:txBody>
+          <a:bodyPr rtlCol="0" anchor="ctr"/>
+          <a:lstStyle/>
+          <a:p>
+            <a:pPr algn="ctr"/>
+          </a:p>
+        </p:txBody>
+      </p:sp>
+      <p:sp>
+        <p:nvSpPr>
+          <p:cNvPr id="15" name="TextBox 14"/>
+          <p:cNvSpPr txBox="1"/>
+          <p:nvPr/>
+        </p:nvSpPr>
+        <p:spPr>
+          <a:xfrm>
+            <a:off x="2255824" y="2414016"/>
+            <a:ext cx="384048" cy="365760"/>
+          </a:xfrm>
+          <a:prstGeom prst="rect">
+            <a:avLst/>
+          </a:prstGeom>
+          <a:noFill/>
+        </p:spPr>
+        <p:txBody>
+          <a:bodyPr wrap="none">
+            <a:spAutoFit/>
+          </a:bodyPr>
+          <a:lstStyle/>
+          <a:p>
+            <a:pPr algn="ctr">
+              <a:spcAft>
+                <a:spcPts val="1000"/>
+              </a:spcAft>
+            </a:pPr>
+            <a:r>
+              <a:rPr sz="1600" b="1">
                 <a:solidFill>
-                  <a:srgbClr val="5A606E"/>
+                  <a:srgbClr val="FFFFFF"/>
                 </a:solidFill>
                 <a:latin typeface="Microsoft YaHei"/>
               </a:rPr>
-              <a:t>写80字「赛事快讯」（≥3次变化）</a:t>
-            </a:r>
-          </a:p>
-          <a:p>
-            <a:pPr>
+              <a:t>2</a:t>
+            </a:r>
+          </a:p>
+        </p:txBody>
+      </p:sp>
+      <p:sp>
+        <p:nvSpPr>
+          <p:cNvPr id="16" name="TextBox 15"/>
+          <p:cNvSpPr txBox="1"/>
+          <p:nvPr/>
+        </p:nvSpPr>
+        <p:spPr>
+          <a:xfrm>
+            <a:off x="2758744" y="2377440"/>
+            <a:ext cx="7772400" cy="502920"/>
+          </a:xfrm>
+          <a:prstGeom prst="rect">
+            <a:avLst/>
+          </a:prstGeom>
+          <a:noFill/>
+        </p:spPr>
+        <p:txBody>
+          <a:bodyPr wrap="none">
+            <a:spAutoFit/>
+          </a:bodyPr>
+          <a:lstStyle/>
+          <a:p>
+            <a:pPr algn="l">
               <a:spcAft>
-                <a:spcPts val="1600"/>
+                <a:spcPts val="1000"/>
               </a:spcAft>
             </a:pPr>
             <a:r>
-              <a:rPr sz="2600" b="1">
+              <a:rPr sz="2400" b="0">
                 <a:solidFill>
-                  <a:srgbClr val="FFB799"/>
+                  <a:srgbClr val="502814"/>
                 </a:solidFill>
                 <a:latin typeface="Microsoft YaHei"/>
               </a:rPr>
-              <a:t>链接  </a:t>
-            </a:r>
-            <a:r>
-              <a:rPr sz="2600" b="0">
-                <a:solidFill>
-                  <a:srgbClr val="5A606E"/>
-                </a:solidFill>
-                <a:latin typeface="Microsoft YaHei"/>
-              </a:rPr>
-              <a:t>作者吴承恩，成书明代，再写一个经典情节</a:t>
+              <a:t>链接：作者吴承恩，成书明代，再写一个经典情节</a:t>
             </a:r>
           </a:p>
         </p:txBody>

</xml_diff>